<commit_message>
fix: complete PPT Team deck repair gates
</commit_message>
<xml_diff>
--- a/examples/mvp_zou/mvp_zou.pptx
+++ b/examples/mvp_zou/mvp_zou.pptx
@@ -131,7 +131,7 @@
           <p:cNvPr id="2" name="标题 1">
             <a:extLst>
               <a:ext uri="{FF2B5EF4-FFF2-40B4-BE49-F238E27FC236}">
-                <a16:creationId xmlns:a16="http://schemas.microsoft.com/office/drawing/2014/main" id="{9BDD4709-71F5-2464-EBF2-BA0284E8A7CF}"/>
+                <a16:creationId xmlns:a16="http://schemas.microsoft.com/office/drawing/2014/main" id="{2A2C7AB1-5C15-F50D-A265-905A9E2159EB}"/>
               </a:ext>
             </a:extLst>
           </p:cNvPr>
@@ -168,7 +168,7 @@
           <p:cNvPr id="3" name="副标题 2">
             <a:extLst>
               <a:ext uri="{FF2B5EF4-FFF2-40B4-BE49-F238E27FC236}">
-                <a16:creationId xmlns:a16="http://schemas.microsoft.com/office/drawing/2014/main" id="{F03853D1-BE7C-3A68-17D4-A5A10691DBDD}"/>
+                <a16:creationId xmlns:a16="http://schemas.microsoft.com/office/drawing/2014/main" id="{5DFD1263-2AB0-0FB3-C223-BF8D76B75962}"/>
               </a:ext>
             </a:extLst>
           </p:cNvPr>
@@ -238,7 +238,7 @@
           <p:cNvPr id="4" name="日期占位符 3">
             <a:extLst>
               <a:ext uri="{FF2B5EF4-FFF2-40B4-BE49-F238E27FC236}">
-                <a16:creationId xmlns:a16="http://schemas.microsoft.com/office/drawing/2014/main" id="{17CE7B16-556E-330A-84ED-B802695A1FE5}"/>
+                <a16:creationId xmlns:a16="http://schemas.microsoft.com/office/drawing/2014/main" id="{7BF7C4C2-6BAE-D20C-0E07-B486EA70A354}"/>
               </a:ext>
             </a:extLst>
           </p:cNvPr>
@@ -254,9 +254,9 @@
           <a:bodyPr/>
           <a:lstStyle/>
           <a:p>
-            <a:fld id="{B4C0A41F-5E1D-4B08-9376-453926655FAB}" type="datetimeFigureOut">
+            <a:fld id="{2EA59CA5-E603-46AA-B66C-16837A232DBA}" type="datetimeFigureOut">
               <a:rPr lang="zh-CN" altLang="en-US" smtClean="0"/>
-              <a:t>2026/9/15</a:t>
+              <a:t>2026/9/17</a:t>
             </a:fld>
             <a:endParaRPr lang="zh-CN" altLang="en-US"/>
           </a:p>
@@ -267,7 +267,7 @@
           <p:cNvPr id="5" name="页脚占位符 4">
             <a:extLst>
               <a:ext uri="{FF2B5EF4-FFF2-40B4-BE49-F238E27FC236}">
-                <a16:creationId xmlns:a16="http://schemas.microsoft.com/office/drawing/2014/main" id="{3F50A51F-7FB0-0CCE-3FB9-7D8414A0639B}"/>
+                <a16:creationId xmlns:a16="http://schemas.microsoft.com/office/drawing/2014/main" id="{96606C5C-8A8A-3F12-A75B-8920FD45B02A}"/>
               </a:ext>
             </a:extLst>
           </p:cNvPr>
@@ -292,7 +292,7 @@
           <p:cNvPr id="6" name="灯片编号占位符 5">
             <a:extLst>
               <a:ext uri="{FF2B5EF4-FFF2-40B4-BE49-F238E27FC236}">
-                <a16:creationId xmlns:a16="http://schemas.microsoft.com/office/drawing/2014/main" id="{0B69E5AD-F0A0-9B2F-5D07-D9C66B5869F0}"/>
+                <a16:creationId xmlns:a16="http://schemas.microsoft.com/office/drawing/2014/main" id="{F7CF3F2B-A5C5-EBF9-AFB4-D87912E96B93}"/>
               </a:ext>
             </a:extLst>
           </p:cNvPr>
@@ -308,7 +308,7 @@
           <a:bodyPr/>
           <a:lstStyle/>
           <a:p>
-            <a:fld id="{7C925888-E23A-4AA5-A7F6-3D447E07EE5F}" type="slidenum">
+            <a:fld id="{F5AFB413-F331-4B80-9467-94C982ED185C}" type="slidenum">
               <a:rPr lang="zh-CN" altLang="en-US" smtClean="0"/>
               <a:t>‹#›</a:t>
             </a:fld>
@@ -319,7 +319,7 @@
     </p:spTree>
     <p:extLst>
       <p:ext uri="{BB962C8B-B14F-4D97-AF65-F5344CB8AC3E}">
-        <p14:creationId xmlns:p14="http://schemas.microsoft.com/office/powerpoint/2010/main" val="875384840"/>
+        <p14:creationId xmlns:p14="http://schemas.microsoft.com/office/powerpoint/2010/main" val="1434218278"/>
       </p:ext>
     </p:extLst>
   </p:cSld>
@@ -351,7 +351,7 @@
           <p:cNvPr id="2" name="标题 1">
             <a:extLst>
               <a:ext uri="{FF2B5EF4-FFF2-40B4-BE49-F238E27FC236}">
-                <a16:creationId xmlns:a16="http://schemas.microsoft.com/office/drawing/2014/main" id="{FC93A164-15CA-87C1-A628-95015A89C7EC}"/>
+                <a16:creationId xmlns:a16="http://schemas.microsoft.com/office/drawing/2014/main" id="{533E31C8-B670-256D-43CA-9E8DC943F1A1}"/>
               </a:ext>
             </a:extLst>
           </p:cNvPr>
@@ -379,7 +379,7 @@
           <p:cNvPr id="3" name="竖排文字占位符 2">
             <a:extLst>
               <a:ext uri="{FF2B5EF4-FFF2-40B4-BE49-F238E27FC236}">
-                <a16:creationId xmlns:a16="http://schemas.microsoft.com/office/drawing/2014/main" id="{10BA6599-54A9-E415-BD47-FBD81B908F28}"/>
+                <a16:creationId xmlns:a16="http://schemas.microsoft.com/office/drawing/2014/main" id="{A86BC4D5-5804-C38A-8B7F-D29C545D66B7}"/>
               </a:ext>
             </a:extLst>
           </p:cNvPr>
@@ -436,7 +436,7 @@
           <p:cNvPr id="4" name="日期占位符 3">
             <a:extLst>
               <a:ext uri="{FF2B5EF4-FFF2-40B4-BE49-F238E27FC236}">
-                <a16:creationId xmlns:a16="http://schemas.microsoft.com/office/drawing/2014/main" id="{896F5FEB-43C7-49B2-03C5-65EA7F45F30C}"/>
+                <a16:creationId xmlns:a16="http://schemas.microsoft.com/office/drawing/2014/main" id="{78551E18-F346-1F00-C5A3-F9F430F158C6}"/>
               </a:ext>
             </a:extLst>
           </p:cNvPr>
@@ -452,9 +452,9 @@
           <a:bodyPr/>
           <a:lstStyle/>
           <a:p>
-            <a:fld id="{B4C0A41F-5E1D-4B08-9376-453926655FAB}" type="datetimeFigureOut">
+            <a:fld id="{2EA59CA5-E603-46AA-B66C-16837A232DBA}" type="datetimeFigureOut">
               <a:rPr lang="zh-CN" altLang="en-US" smtClean="0"/>
-              <a:t>2026/9/15</a:t>
+              <a:t>2026/9/17</a:t>
             </a:fld>
             <a:endParaRPr lang="zh-CN" altLang="en-US"/>
           </a:p>
@@ -465,7 +465,7 @@
           <p:cNvPr id="5" name="页脚占位符 4">
             <a:extLst>
               <a:ext uri="{FF2B5EF4-FFF2-40B4-BE49-F238E27FC236}">
-                <a16:creationId xmlns:a16="http://schemas.microsoft.com/office/drawing/2014/main" id="{75E27103-5D3C-C00D-808C-AE61B744BBD5}"/>
+                <a16:creationId xmlns:a16="http://schemas.microsoft.com/office/drawing/2014/main" id="{C4D6D4FE-EF47-2B68-44F3-5048B32BC052}"/>
               </a:ext>
             </a:extLst>
           </p:cNvPr>
@@ -490,7 +490,7 @@
           <p:cNvPr id="6" name="灯片编号占位符 5">
             <a:extLst>
               <a:ext uri="{FF2B5EF4-FFF2-40B4-BE49-F238E27FC236}">
-                <a16:creationId xmlns:a16="http://schemas.microsoft.com/office/drawing/2014/main" id="{EE276463-39AE-FE7E-A012-48FC88DAD708}"/>
+                <a16:creationId xmlns:a16="http://schemas.microsoft.com/office/drawing/2014/main" id="{8F2CB862-0DD8-BDD0-21B8-E24DC25A12CD}"/>
               </a:ext>
             </a:extLst>
           </p:cNvPr>
@@ -506,7 +506,7 @@
           <a:bodyPr/>
           <a:lstStyle/>
           <a:p>
-            <a:fld id="{7C925888-E23A-4AA5-A7F6-3D447E07EE5F}" type="slidenum">
+            <a:fld id="{F5AFB413-F331-4B80-9467-94C982ED185C}" type="slidenum">
               <a:rPr lang="zh-CN" altLang="en-US" smtClean="0"/>
               <a:t>‹#›</a:t>
             </a:fld>
@@ -517,7 +517,7 @@
     </p:spTree>
     <p:extLst>
       <p:ext uri="{BB962C8B-B14F-4D97-AF65-F5344CB8AC3E}">
-        <p14:creationId xmlns:p14="http://schemas.microsoft.com/office/powerpoint/2010/main" val="923608473"/>
+        <p14:creationId xmlns:p14="http://schemas.microsoft.com/office/powerpoint/2010/main" val="2477940850"/>
       </p:ext>
     </p:extLst>
   </p:cSld>
@@ -549,7 +549,7 @@
           <p:cNvPr id="2" name="竖排标题 1">
             <a:extLst>
               <a:ext uri="{FF2B5EF4-FFF2-40B4-BE49-F238E27FC236}">
-                <a16:creationId xmlns:a16="http://schemas.microsoft.com/office/drawing/2014/main" id="{5CEC0076-6927-051B-5422-22919C802B6C}"/>
+                <a16:creationId xmlns:a16="http://schemas.microsoft.com/office/drawing/2014/main" id="{D3984BA1-D28F-0B2D-FE19-5D217086F2AF}"/>
               </a:ext>
             </a:extLst>
           </p:cNvPr>
@@ -582,7 +582,7 @@
           <p:cNvPr id="3" name="竖排文字占位符 2">
             <a:extLst>
               <a:ext uri="{FF2B5EF4-FFF2-40B4-BE49-F238E27FC236}">
-                <a16:creationId xmlns:a16="http://schemas.microsoft.com/office/drawing/2014/main" id="{BDF8CE26-F97B-A664-B11F-8B7B9841E88C}"/>
+                <a16:creationId xmlns:a16="http://schemas.microsoft.com/office/drawing/2014/main" id="{D7AC1BE4-431D-9696-2C05-BCE61130D949}"/>
               </a:ext>
             </a:extLst>
           </p:cNvPr>
@@ -644,7 +644,7 @@
           <p:cNvPr id="4" name="日期占位符 3">
             <a:extLst>
               <a:ext uri="{FF2B5EF4-FFF2-40B4-BE49-F238E27FC236}">
-                <a16:creationId xmlns:a16="http://schemas.microsoft.com/office/drawing/2014/main" id="{F3BC9EAA-4D8F-635D-1686-79A31A03BAC5}"/>
+                <a16:creationId xmlns:a16="http://schemas.microsoft.com/office/drawing/2014/main" id="{25959173-D3CE-0C04-93C4-8A1A02FC35E9}"/>
               </a:ext>
             </a:extLst>
           </p:cNvPr>
@@ -660,9 +660,9 @@
           <a:bodyPr/>
           <a:lstStyle/>
           <a:p>
-            <a:fld id="{B4C0A41F-5E1D-4B08-9376-453926655FAB}" type="datetimeFigureOut">
+            <a:fld id="{2EA59CA5-E603-46AA-B66C-16837A232DBA}" type="datetimeFigureOut">
               <a:rPr lang="zh-CN" altLang="en-US" smtClean="0"/>
-              <a:t>2026/9/15</a:t>
+              <a:t>2026/9/17</a:t>
             </a:fld>
             <a:endParaRPr lang="zh-CN" altLang="en-US"/>
           </a:p>
@@ -673,7 +673,7 @@
           <p:cNvPr id="5" name="页脚占位符 4">
             <a:extLst>
               <a:ext uri="{FF2B5EF4-FFF2-40B4-BE49-F238E27FC236}">
-                <a16:creationId xmlns:a16="http://schemas.microsoft.com/office/drawing/2014/main" id="{37D40C12-DDEC-E95B-22B2-5DD5C8E15BCE}"/>
+                <a16:creationId xmlns:a16="http://schemas.microsoft.com/office/drawing/2014/main" id="{54C0C748-0799-8B88-D236-C6AF76760218}"/>
               </a:ext>
             </a:extLst>
           </p:cNvPr>
@@ -698,7 +698,7 @@
           <p:cNvPr id="6" name="灯片编号占位符 5">
             <a:extLst>
               <a:ext uri="{FF2B5EF4-FFF2-40B4-BE49-F238E27FC236}">
-                <a16:creationId xmlns:a16="http://schemas.microsoft.com/office/drawing/2014/main" id="{B7417D84-79F7-4069-010F-6986F2B50AD4}"/>
+                <a16:creationId xmlns:a16="http://schemas.microsoft.com/office/drawing/2014/main" id="{3870C26E-CEAE-6886-EE3C-2676745B8E29}"/>
               </a:ext>
             </a:extLst>
           </p:cNvPr>
@@ -714,7 +714,7 @@
           <a:bodyPr/>
           <a:lstStyle/>
           <a:p>
-            <a:fld id="{7C925888-E23A-4AA5-A7F6-3D447E07EE5F}" type="slidenum">
+            <a:fld id="{F5AFB413-F331-4B80-9467-94C982ED185C}" type="slidenum">
               <a:rPr lang="zh-CN" altLang="en-US" smtClean="0"/>
               <a:t>‹#›</a:t>
             </a:fld>
@@ -725,7 +725,7 @@
     </p:spTree>
     <p:extLst>
       <p:ext uri="{BB962C8B-B14F-4D97-AF65-F5344CB8AC3E}">
-        <p14:creationId xmlns:p14="http://schemas.microsoft.com/office/powerpoint/2010/main" val="2932152420"/>
+        <p14:creationId xmlns:p14="http://schemas.microsoft.com/office/powerpoint/2010/main" val="3326220070"/>
       </p:ext>
     </p:extLst>
   </p:cSld>
@@ -757,7 +757,7 @@
           <p:cNvPr id="2" name="标题 1">
             <a:extLst>
               <a:ext uri="{FF2B5EF4-FFF2-40B4-BE49-F238E27FC236}">
-                <a16:creationId xmlns:a16="http://schemas.microsoft.com/office/drawing/2014/main" id="{175A05E2-0655-F62C-32ED-AC616048D52D}"/>
+                <a16:creationId xmlns:a16="http://schemas.microsoft.com/office/drawing/2014/main" id="{A42D87B3-EE1E-D85D-EB90-D618E15EB8D9}"/>
               </a:ext>
             </a:extLst>
           </p:cNvPr>
@@ -785,7 +785,7 @@
           <p:cNvPr id="3" name="内容占位符 2">
             <a:extLst>
               <a:ext uri="{FF2B5EF4-FFF2-40B4-BE49-F238E27FC236}">
-                <a16:creationId xmlns:a16="http://schemas.microsoft.com/office/drawing/2014/main" id="{A525D25F-2FB0-9D4C-70A9-45BB69922CF1}"/>
+                <a16:creationId xmlns:a16="http://schemas.microsoft.com/office/drawing/2014/main" id="{8341489C-3EDE-C2AA-ACBE-14FBFE1F2749}"/>
               </a:ext>
             </a:extLst>
           </p:cNvPr>
@@ -842,7 +842,7 @@
           <p:cNvPr id="4" name="日期占位符 3">
             <a:extLst>
               <a:ext uri="{FF2B5EF4-FFF2-40B4-BE49-F238E27FC236}">
-                <a16:creationId xmlns:a16="http://schemas.microsoft.com/office/drawing/2014/main" id="{08F69ECE-7C3D-3348-C8B1-C83BB26822BD}"/>
+                <a16:creationId xmlns:a16="http://schemas.microsoft.com/office/drawing/2014/main" id="{F0640947-9937-4731-F44F-0567F66E34FE}"/>
               </a:ext>
             </a:extLst>
           </p:cNvPr>
@@ -858,9 +858,9 @@
           <a:bodyPr/>
           <a:lstStyle/>
           <a:p>
-            <a:fld id="{B4C0A41F-5E1D-4B08-9376-453926655FAB}" type="datetimeFigureOut">
+            <a:fld id="{2EA59CA5-E603-46AA-B66C-16837A232DBA}" type="datetimeFigureOut">
               <a:rPr lang="zh-CN" altLang="en-US" smtClean="0"/>
-              <a:t>2026/9/15</a:t>
+              <a:t>2026/9/17</a:t>
             </a:fld>
             <a:endParaRPr lang="zh-CN" altLang="en-US"/>
           </a:p>
@@ -871,7 +871,7 @@
           <p:cNvPr id="5" name="页脚占位符 4">
             <a:extLst>
               <a:ext uri="{FF2B5EF4-FFF2-40B4-BE49-F238E27FC236}">
-                <a16:creationId xmlns:a16="http://schemas.microsoft.com/office/drawing/2014/main" id="{D2A8A052-3399-22AF-D693-64C1232B1A05}"/>
+                <a16:creationId xmlns:a16="http://schemas.microsoft.com/office/drawing/2014/main" id="{ED254052-EE55-1433-CF50-4D64FDB03B04}"/>
               </a:ext>
             </a:extLst>
           </p:cNvPr>
@@ -896,7 +896,7 @@
           <p:cNvPr id="6" name="灯片编号占位符 5">
             <a:extLst>
               <a:ext uri="{FF2B5EF4-FFF2-40B4-BE49-F238E27FC236}">
-                <a16:creationId xmlns:a16="http://schemas.microsoft.com/office/drawing/2014/main" id="{95AF4967-39EE-B4F4-E335-558A615DFADB}"/>
+                <a16:creationId xmlns:a16="http://schemas.microsoft.com/office/drawing/2014/main" id="{AA2D7BBA-7771-B764-AF3F-92259EF15411}"/>
               </a:ext>
             </a:extLst>
           </p:cNvPr>
@@ -912,7 +912,7 @@
           <a:bodyPr/>
           <a:lstStyle/>
           <a:p>
-            <a:fld id="{7C925888-E23A-4AA5-A7F6-3D447E07EE5F}" type="slidenum">
+            <a:fld id="{F5AFB413-F331-4B80-9467-94C982ED185C}" type="slidenum">
               <a:rPr lang="zh-CN" altLang="en-US" smtClean="0"/>
               <a:t>‹#›</a:t>
             </a:fld>
@@ -923,7 +923,7 @@
     </p:spTree>
     <p:extLst>
       <p:ext uri="{BB962C8B-B14F-4D97-AF65-F5344CB8AC3E}">
-        <p14:creationId xmlns:p14="http://schemas.microsoft.com/office/powerpoint/2010/main" val="2009039801"/>
+        <p14:creationId xmlns:p14="http://schemas.microsoft.com/office/powerpoint/2010/main" val="3012275629"/>
       </p:ext>
     </p:extLst>
   </p:cSld>
@@ -955,7 +955,7 @@
           <p:cNvPr id="2" name="标题 1">
             <a:extLst>
               <a:ext uri="{FF2B5EF4-FFF2-40B4-BE49-F238E27FC236}">
-                <a16:creationId xmlns:a16="http://schemas.microsoft.com/office/drawing/2014/main" id="{391B283D-958F-2922-8E97-3939FE9D0D1B}"/>
+                <a16:creationId xmlns:a16="http://schemas.microsoft.com/office/drawing/2014/main" id="{D8FF47AF-D0F6-C687-6E65-C51C2536A34D}"/>
               </a:ext>
             </a:extLst>
           </p:cNvPr>
@@ -992,7 +992,7 @@
           <p:cNvPr id="3" name="文本占位符 2">
             <a:extLst>
               <a:ext uri="{FF2B5EF4-FFF2-40B4-BE49-F238E27FC236}">
-                <a16:creationId xmlns:a16="http://schemas.microsoft.com/office/drawing/2014/main" id="{9DFE3D37-54D2-9B80-90AA-26EDB79DBB58}"/>
+                <a16:creationId xmlns:a16="http://schemas.microsoft.com/office/drawing/2014/main" id="{604526D0-C298-FB58-38F5-0970B840FD3D}"/>
               </a:ext>
             </a:extLst>
           </p:cNvPr>
@@ -1117,7 +1117,7 @@
           <p:cNvPr id="4" name="日期占位符 3">
             <a:extLst>
               <a:ext uri="{FF2B5EF4-FFF2-40B4-BE49-F238E27FC236}">
-                <a16:creationId xmlns:a16="http://schemas.microsoft.com/office/drawing/2014/main" id="{B7DBFC79-C227-1C89-10F4-D93DD892A4FB}"/>
+                <a16:creationId xmlns:a16="http://schemas.microsoft.com/office/drawing/2014/main" id="{A8961FB8-3B15-D53A-4918-89D024FC43A4}"/>
               </a:ext>
             </a:extLst>
           </p:cNvPr>
@@ -1133,9 +1133,9 @@
           <a:bodyPr/>
           <a:lstStyle/>
           <a:p>
-            <a:fld id="{B4C0A41F-5E1D-4B08-9376-453926655FAB}" type="datetimeFigureOut">
+            <a:fld id="{2EA59CA5-E603-46AA-B66C-16837A232DBA}" type="datetimeFigureOut">
               <a:rPr lang="zh-CN" altLang="en-US" smtClean="0"/>
-              <a:t>2026/9/15</a:t>
+              <a:t>2026/9/17</a:t>
             </a:fld>
             <a:endParaRPr lang="zh-CN" altLang="en-US"/>
           </a:p>
@@ -1146,7 +1146,7 @@
           <p:cNvPr id="5" name="页脚占位符 4">
             <a:extLst>
               <a:ext uri="{FF2B5EF4-FFF2-40B4-BE49-F238E27FC236}">
-                <a16:creationId xmlns:a16="http://schemas.microsoft.com/office/drawing/2014/main" id="{9884E06A-28AB-9502-336B-52DEC515189C}"/>
+                <a16:creationId xmlns:a16="http://schemas.microsoft.com/office/drawing/2014/main" id="{02C5184E-3565-51A6-0B73-F0BF4A6CB427}"/>
               </a:ext>
             </a:extLst>
           </p:cNvPr>
@@ -1171,7 +1171,7 @@
           <p:cNvPr id="6" name="灯片编号占位符 5">
             <a:extLst>
               <a:ext uri="{FF2B5EF4-FFF2-40B4-BE49-F238E27FC236}">
-                <a16:creationId xmlns:a16="http://schemas.microsoft.com/office/drawing/2014/main" id="{5B3B55C2-2E99-A7EB-0AC7-1AC48AA119BC}"/>
+                <a16:creationId xmlns:a16="http://schemas.microsoft.com/office/drawing/2014/main" id="{66D3D221-D86F-B304-3DD1-EE2487C3DAE9}"/>
               </a:ext>
             </a:extLst>
           </p:cNvPr>
@@ -1187,7 +1187,7 @@
           <a:bodyPr/>
           <a:lstStyle/>
           <a:p>
-            <a:fld id="{7C925888-E23A-4AA5-A7F6-3D447E07EE5F}" type="slidenum">
+            <a:fld id="{F5AFB413-F331-4B80-9467-94C982ED185C}" type="slidenum">
               <a:rPr lang="zh-CN" altLang="en-US" smtClean="0"/>
               <a:t>‹#›</a:t>
             </a:fld>
@@ -1198,7 +1198,7 @@
     </p:spTree>
     <p:extLst>
       <p:ext uri="{BB962C8B-B14F-4D97-AF65-F5344CB8AC3E}">
-        <p14:creationId xmlns:p14="http://schemas.microsoft.com/office/powerpoint/2010/main" val="3557407912"/>
+        <p14:creationId xmlns:p14="http://schemas.microsoft.com/office/powerpoint/2010/main" val="1404130890"/>
       </p:ext>
     </p:extLst>
   </p:cSld>
@@ -1230,7 +1230,7 @@
           <p:cNvPr id="2" name="标题 1">
             <a:extLst>
               <a:ext uri="{FF2B5EF4-FFF2-40B4-BE49-F238E27FC236}">
-                <a16:creationId xmlns:a16="http://schemas.microsoft.com/office/drawing/2014/main" id="{CB6B9020-0F1E-C7FB-25CB-F502512205F5}"/>
+                <a16:creationId xmlns:a16="http://schemas.microsoft.com/office/drawing/2014/main" id="{33B5F610-7717-C2B6-2002-0C310FFC7DFE}"/>
               </a:ext>
             </a:extLst>
           </p:cNvPr>
@@ -1258,7 +1258,7 @@
           <p:cNvPr id="3" name="内容占位符 2">
             <a:extLst>
               <a:ext uri="{FF2B5EF4-FFF2-40B4-BE49-F238E27FC236}">
-                <a16:creationId xmlns:a16="http://schemas.microsoft.com/office/drawing/2014/main" id="{B1CAC350-D4E6-D013-94CD-9E7A4F266012}"/>
+                <a16:creationId xmlns:a16="http://schemas.microsoft.com/office/drawing/2014/main" id="{DDFD0238-6891-C15F-639B-6A5C01B374BE}"/>
               </a:ext>
             </a:extLst>
           </p:cNvPr>
@@ -1320,7 +1320,7 @@
           <p:cNvPr id="4" name="内容占位符 3">
             <a:extLst>
               <a:ext uri="{FF2B5EF4-FFF2-40B4-BE49-F238E27FC236}">
-                <a16:creationId xmlns:a16="http://schemas.microsoft.com/office/drawing/2014/main" id="{8C832245-119F-E603-4A7F-C694D528BC66}"/>
+                <a16:creationId xmlns:a16="http://schemas.microsoft.com/office/drawing/2014/main" id="{9048B407-6B81-CC9A-7515-28C347FAB9E2}"/>
               </a:ext>
             </a:extLst>
           </p:cNvPr>
@@ -1382,7 +1382,7 @@
           <p:cNvPr id="5" name="日期占位符 4">
             <a:extLst>
               <a:ext uri="{FF2B5EF4-FFF2-40B4-BE49-F238E27FC236}">
-                <a16:creationId xmlns:a16="http://schemas.microsoft.com/office/drawing/2014/main" id="{572FE1E3-6129-5B24-7474-CD48665A8F11}"/>
+                <a16:creationId xmlns:a16="http://schemas.microsoft.com/office/drawing/2014/main" id="{74BF5D5C-51BC-7879-5809-FD5BA5C31BAD}"/>
               </a:ext>
             </a:extLst>
           </p:cNvPr>
@@ -1398,9 +1398,9 @@
           <a:bodyPr/>
           <a:lstStyle/>
           <a:p>
-            <a:fld id="{B4C0A41F-5E1D-4B08-9376-453926655FAB}" type="datetimeFigureOut">
+            <a:fld id="{2EA59CA5-E603-46AA-B66C-16837A232DBA}" type="datetimeFigureOut">
               <a:rPr lang="zh-CN" altLang="en-US" smtClean="0"/>
-              <a:t>2026/9/15</a:t>
+              <a:t>2026/9/17</a:t>
             </a:fld>
             <a:endParaRPr lang="zh-CN" altLang="en-US"/>
           </a:p>
@@ -1411,7 +1411,7 @@
           <p:cNvPr id="6" name="页脚占位符 5">
             <a:extLst>
               <a:ext uri="{FF2B5EF4-FFF2-40B4-BE49-F238E27FC236}">
-                <a16:creationId xmlns:a16="http://schemas.microsoft.com/office/drawing/2014/main" id="{FE062827-93B7-B59E-02F3-DB7BDA0C51C9}"/>
+                <a16:creationId xmlns:a16="http://schemas.microsoft.com/office/drawing/2014/main" id="{F45DE035-98A7-8430-9E6D-5673877A8DB9}"/>
               </a:ext>
             </a:extLst>
           </p:cNvPr>
@@ -1436,7 +1436,7 @@
           <p:cNvPr id="7" name="灯片编号占位符 6">
             <a:extLst>
               <a:ext uri="{FF2B5EF4-FFF2-40B4-BE49-F238E27FC236}">
-                <a16:creationId xmlns:a16="http://schemas.microsoft.com/office/drawing/2014/main" id="{BFD7B131-39D7-4CDB-923E-C86A746F143F}"/>
+                <a16:creationId xmlns:a16="http://schemas.microsoft.com/office/drawing/2014/main" id="{525125F8-1E2A-5404-4690-AB648483DAE4}"/>
               </a:ext>
             </a:extLst>
           </p:cNvPr>
@@ -1452,7 +1452,7 @@
           <a:bodyPr/>
           <a:lstStyle/>
           <a:p>
-            <a:fld id="{7C925888-E23A-4AA5-A7F6-3D447E07EE5F}" type="slidenum">
+            <a:fld id="{F5AFB413-F331-4B80-9467-94C982ED185C}" type="slidenum">
               <a:rPr lang="zh-CN" altLang="en-US" smtClean="0"/>
               <a:t>‹#›</a:t>
             </a:fld>
@@ -1463,7 +1463,7 @@
     </p:spTree>
     <p:extLst>
       <p:ext uri="{BB962C8B-B14F-4D97-AF65-F5344CB8AC3E}">
-        <p14:creationId xmlns:p14="http://schemas.microsoft.com/office/powerpoint/2010/main" val="870921245"/>
+        <p14:creationId xmlns:p14="http://schemas.microsoft.com/office/powerpoint/2010/main" val="566747858"/>
       </p:ext>
     </p:extLst>
   </p:cSld>
@@ -1495,7 +1495,7 @@
           <p:cNvPr id="2" name="标题 1">
             <a:extLst>
               <a:ext uri="{FF2B5EF4-FFF2-40B4-BE49-F238E27FC236}">
-                <a16:creationId xmlns:a16="http://schemas.microsoft.com/office/drawing/2014/main" id="{D4931C46-0CC6-F315-85B5-820B281CFD71}"/>
+                <a16:creationId xmlns:a16="http://schemas.microsoft.com/office/drawing/2014/main" id="{72B2FE7C-C7D9-D471-CF3A-CF2DDDAA6041}"/>
               </a:ext>
             </a:extLst>
           </p:cNvPr>
@@ -1528,7 +1528,7 @@
           <p:cNvPr id="3" name="文本占位符 2">
             <a:extLst>
               <a:ext uri="{FF2B5EF4-FFF2-40B4-BE49-F238E27FC236}">
-                <a16:creationId xmlns:a16="http://schemas.microsoft.com/office/drawing/2014/main" id="{587A8A16-63C6-09D9-C67B-0C226D840BE7}"/>
+                <a16:creationId xmlns:a16="http://schemas.microsoft.com/office/drawing/2014/main" id="{E8339919-8FF9-F77E-7F33-BB17D178D462}"/>
               </a:ext>
             </a:extLst>
           </p:cNvPr>
@@ -1599,7 +1599,7 @@
           <p:cNvPr id="4" name="内容占位符 3">
             <a:extLst>
               <a:ext uri="{FF2B5EF4-FFF2-40B4-BE49-F238E27FC236}">
-                <a16:creationId xmlns:a16="http://schemas.microsoft.com/office/drawing/2014/main" id="{E8A1A68A-0599-B81B-85B5-F89C4CD5DAE3}"/>
+                <a16:creationId xmlns:a16="http://schemas.microsoft.com/office/drawing/2014/main" id="{24CB2171-7C74-E2F7-3179-710653CA8D49}"/>
               </a:ext>
             </a:extLst>
           </p:cNvPr>
@@ -1661,7 +1661,7 @@
           <p:cNvPr id="5" name="文本占位符 4">
             <a:extLst>
               <a:ext uri="{FF2B5EF4-FFF2-40B4-BE49-F238E27FC236}">
-                <a16:creationId xmlns:a16="http://schemas.microsoft.com/office/drawing/2014/main" id="{14823429-7507-4E9E-3556-678947BA3E82}"/>
+                <a16:creationId xmlns:a16="http://schemas.microsoft.com/office/drawing/2014/main" id="{FBA51404-ACAB-7E77-F122-DFF44E3EE9C3}"/>
               </a:ext>
             </a:extLst>
           </p:cNvPr>
@@ -1732,7 +1732,7 @@
           <p:cNvPr id="6" name="内容占位符 5">
             <a:extLst>
               <a:ext uri="{FF2B5EF4-FFF2-40B4-BE49-F238E27FC236}">
-                <a16:creationId xmlns:a16="http://schemas.microsoft.com/office/drawing/2014/main" id="{1260D4FD-BE88-42E5-D7B8-0BFDA8950BDF}"/>
+                <a16:creationId xmlns:a16="http://schemas.microsoft.com/office/drawing/2014/main" id="{4F44F140-D460-D3DA-7A86-1833A50ECA6E}"/>
               </a:ext>
             </a:extLst>
           </p:cNvPr>
@@ -1794,7 +1794,7 @@
           <p:cNvPr id="7" name="日期占位符 6">
             <a:extLst>
               <a:ext uri="{FF2B5EF4-FFF2-40B4-BE49-F238E27FC236}">
-                <a16:creationId xmlns:a16="http://schemas.microsoft.com/office/drawing/2014/main" id="{4F77067B-C1B5-51BC-9668-F15199C6FCDB}"/>
+                <a16:creationId xmlns:a16="http://schemas.microsoft.com/office/drawing/2014/main" id="{5A7AE25C-80AF-7627-428F-0C0AD1FF33D6}"/>
               </a:ext>
             </a:extLst>
           </p:cNvPr>
@@ -1810,9 +1810,9 @@
           <a:bodyPr/>
           <a:lstStyle/>
           <a:p>
-            <a:fld id="{B4C0A41F-5E1D-4B08-9376-453926655FAB}" type="datetimeFigureOut">
+            <a:fld id="{2EA59CA5-E603-46AA-B66C-16837A232DBA}" type="datetimeFigureOut">
               <a:rPr lang="zh-CN" altLang="en-US" smtClean="0"/>
-              <a:t>2026/9/15</a:t>
+              <a:t>2026/9/17</a:t>
             </a:fld>
             <a:endParaRPr lang="zh-CN" altLang="en-US"/>
           </a:p>
@@ -1823,7 +1823,7 @@
           <p:cNvPr id="8" name="页脚占位符 7">
             <a:extLst>
               <a:ext uri="{FF2B5EF4-FFF2-40B4-BE49-F238E27FC236}">
-                <a16:creationId xmlns:a16="http://schemas.microsoft.com/office/drawing/2014/main" id="{C1036E3D-E299-62DA-CF1C-38B3EEEE9799}"/>
+                <a16:creationId xmlns:a16="http://schemas.microsoft.com/office/drawing/2014/main" id="{1E7B490F-2607-7D36-150D-A937F0B6FC32}"/>
               </a:ext>
             </a:extLst>
           </p:cNvPr>
@@ -1848,7 +1848,7 @@
           <p:cNvPr id="9" name="灯片编号占位符 8">
             <a:extLst>
               <a:ext uri="{FF2B5EF4-FFF2-40B4-BE49-F238E27FC236}">
-                <a16:creationId xmlns:a16="http://schemas.microsoft.com/office/drawing/2014/main" id="{6255C002-85E6-88F3-7321-080F50BE39FD}"/>
+                <a16:creationId xmlns:a16="http://schemas.microsoft.com/office/drawing/2014/main" id="{8B07EA93-412C-89F5-640F-26E86EDA72EA}"/>
               </a:ext>
             </a:extLst>
           </p:cNvPr>
@@ -1864,7 +1864,7 @@
           <a:bodyPr/>
           <a:lstStyle/>
           <a:p>
-            <a:fld id="{7C925888-E23A-4AA5-A7F6-3D447E07EE5F}" type="slidenum">
+            <a:fld id="{F5AFB413-F331-4B80-9467-94C982ED185C}" type="slidenum">
               <a:rPr lang="zh-CN" altLang="en-US" smtClean="0"/>
               <a:t>‹#›</a:t>
             </a:fld>
@@ -1875,7 +1875,7 @@
     </p:spTree>
     <p:extLst>
       <p:ext uri="{BB962C8B-B14F-4D97-AF65-F5344CB8AC3E}">
-        <p14:creationId xmlns:p14="http://schemas.microsoft.com/office/powerpoint/2010/main" val="3751688876"/>
+        <p14:creationId xmlns:p14="http://schemas.microsoft.com/office/powerpoint/2010/main" val="1545376032"/>
       </p:ext>
     </p:extLst>
   </p:cSld>
@@ -1907,7 +1907,7 @@
           <p:cNvPr id="2" name="标题 1">
             <a:extLst>
               <a:ext uri="{FF2B5EF4-FFF2-40B4-BE49-F238E27FC236}">
-                <a16:creationId xmlns:a16="http://schemas.microsoft.com/office/drawing/2014/main" id="{93437306-A8D4-B75E-8BBC-F85176A11A95}"/>
+                <a16:creationId xmlns:a16="http://schemas.microsoft.com/office/drawing/2014/main" id="{13642882-00B4-E517-F0A1-7D6A0F2C0A5C}"/>
               </a:ext>
             </a:extLst>
           </p:cNvPr>
@@ -1935,7 +1935,7 @@
           <p:cNvPr id="3" name="日期占位符 2">
             <a:extLst>
               <a:ext uri="{FF2B5EF4-FFF2-40B4-BE49-F238E27FC236}">
-                <a16:creationId xmlns:a16="http://schemas.microsoft.com/office/drawing/2014/main" id="{56C2B700-6B47-C837-C208-3AEB6C65B7A2}"/>
+                <a16:creationId xmlns:a16="http://schemas.microsoft.com/office/drawing/2014/main" id="{FDA61005-EDF0-8A8E-80BD-B10066560700}"/>
               </a:ext>
             </a:extLst>
           </p:cNvPr>
@@ -1951,9 +1951,9 @@
           <a:bodyPr/>
           <a:lstStyle/>
           <a:p>
-            <a:fld id="{B4C0A41F-5E1D-4B08-9376-453926655FAB}" type="datetimeFigureOut">
+            <a:fld id="{2EA59CA5-E603-46AA-B66C-16837A232DBA}" type="datetimeFigureOut">
               <a:rPr lang="zh-CN" altLang="en-US" smtClean="0"/>
-              <a:t>2026/9/15</a:t>
+              <a:t>2026/9/17</a:t>
             </a:fld>
             <a:endParaRPr lang="zh-CN" altLang="en-US"/>
           </a:p>
@@ -1964,7 +1964,7 @@
           <p:cNvPr id="4" name="页脚占位符 3">
             <a:extLst>
               <a:ext uri="{FF2B5EF4-FFF2-40B4-BE49-F238E27FC236}">
-                <a16:creationId xmlns:a16="http://schemas.microsoft.com/office/drawing/2014/main" id="{CA635118-57DF-ED3D-BF49-2798AA5DF3FC}"/>
+                <a16:creationId xmlns:a16="http://schemas.microsoft.com/office/drawing/2014/main" id="{DEB0EC40-5B29-E0CF-533C-808B51A98451}"/>
               </a:ext>
             </a:extLst>
           </p:cNvPr>
@@ -1989,7 +1989,7 @@
           <p:cNvPr id="5" name="灯片编号占位符 4">
             <a:extLst>
               <a:ext uri="{FF2B5EF4-FFF2-40B4-BE49-F238E27FC236}">
-                <a16:creationId xmlns:a16="http://schemas.microsoft.com/office/drawing/2014/main" id="{39EDC36E-FCF2-7D8A-00B9-DAFB1C57CB5F}"/>
+                <a16:creationId xmlns:a16="http://schemas.microsoft.com/office/drawing/2014/main" id="{42663740-B950-B5A8-2827-91E4B5DA16B6}"/>
               </a:ext>
             </a:extLst>
           </p:cNvPr>
@@ -2005,7 +2005,7 @@
           <a:bodyPr/>
           <a:lstStyle/>
           <a:p>
-            <a:fld id="{7C925888-E23A-4AA5-A7F6-3D447E07EE5F}" type="slidenum">
+            <a:fld id="{F5AFB413-F331-4B80-9467-94C982ED185C}" type="slidenum">
               <a:rPr lang="zh-CN" altLang="en-US" smtClean="0"/>
               <a:t>‹#›</a:t>
             </a:fld>
@@ -2016,7 +2016,7 @@
     </p:spTree>
     <p:extLst>
       <p:ext uri="{BB962C8B-B14F-4D97-AF65-F5344CB8AC3E}">
-        <p14:creationId xmlns:p14="http://schemas.microsoft.com/office/powerpoint/2010/main" val="823829702"/>
+        <p14:creationId xmlns:p14="http://schemas.microsoft.com/office/powerpoint/2010/main" val="2494289439"/>
       </p:ext>
     </p:extLst>
   </p:cSld>
@@ -2048,7 +2048,7 @@
           <p:cNvPr id="2" name="日期占位符 1">
             <a:extLst>
               <a:ext uri="{FF2B5EF4-FFF2-40B4-BE49-F238E27FC236}">
-                <a16:creationId xmlns:a16="http://schemas.microsoft.com/office/drawing/2014/main" id="{A30D8849-8A5E-7792-7EA4-872032F1D8A9}"/>
+                <a16:creationId xmlns:a16="http://schemas.microsoft.com/office/drawing/2014/main" id="{C9911621-5198-25F7-09BE-43882CCA149F}"/>
               </a:ext>
             </a:extLst>
           </p:cNvPr>
@@ -2064,9 +2064,9 @@
           <a:bodyPr/>
           <a:lstStyle/>
           <a:p>
-            <a:fld id="{B4C0A41F-5E1D-4B08-9376-453926655FAB}" type="datetimeFigureOut">
+            <a:fld id="{2EA59CA5-E603-46AA-B66C-16837A232DBA}" type="datetimeFigureOut">
               <a:rPr lang="zh-CN" altLang="en-US" smtClean="0"/>
-              <a:t>2026/9/15</a:t>
+              <a:t>2026/9/17</a:t>
             </a:fld>
             <a:endParaRPr lang="zh-CN" altLang="en-US"/>
           </a:p>
@@ -2077,7 +2077,7 @@
           <p:cNvPr id="3" name="页脚占位符 2">
             <a:extLst>
               <a:ext uri="{FF2B5EF4-FFF2-40B4-BE49-F238E27FC236}">
-                <a16:creationId xmlns:a16="http://schemas.microsoft.com/office/drawing/2014/main" id="{E94AD1DD-640C-5835-A49A-7BB00C398E3A}"/>
+                <a16:creationId xmlns:a16="http://schemas.microsoft.com/office/drawing/2014/main" id="{A6C1F4B3-CD4F-04F1-F608-D76011C23EB3}"/>
               </a:ext>
             </a:extLst>
           </p:cNvPr>
@@ -2102,7 +2102,7 @@
           <p:cNvPr id="4" name="灯片编号占位符 3">
             <a:extLst>
               <a:ext uri="{FF2B5EF4-FFF2-40B4-BE49-F238E27FC236}">
-                <a16:creationId xmlns:a16="http://schemas.microsoft.com/office/drawing/2014/main" id="{1341761B-0D22-787F-CB9E-A391E2672659}"/>
+                <a16:creationId xmlns:a16="http://schemas.microsoft.com/office/drawing/2014/main" id="{36B7C49E-66BC-5407-BDF7-A22CE4B1A73B}"/>
               </a:ext>
             </a:extLst>
           </p:cNvPr>
@@ -2118,7 +2118,7 @@
           <a:bodyPr/>
           <a:lstStyle/>
           <a:p>
-            <a:fld id="{7C925888-E23A-4AA5-A7F6-3D447E07EE5F}" type="slidenum">
+            <a:fld id="{F5AFB413-F331-4B80-9467-94C982ED185C}" type="slidenum">
               <a:rPr lang="zh-CN" altLang="en-US" smtClean="0"/>
               <a:t>‹#›</a:t>
             </a:fld>
@@ -2129,7 +2129,7 @@
     </p:spTree>
     <p:extLst>
       <p:ext uri="{BB962C8B-B14F-4D97-AF65-F5344CB8AC3E}">
-        <p14:creationId xmlns:p14="http://schemas.microsoft.com/office/powerpoint/2010/main" val="1278029050"/>
+        <p14:creationId xmlns:p14="http://schemas.microsoft.com/office/powerpoint/2010/main" val="3499755000"/>
       </p:ext>
     </p:extLst>
   </p:cSld>
@@ -2161,7 +2161,7 @@
           <p:cNvPr id="2" name="标题 1">
             <a:extLst>
               <a:ext uri="{FF2B5EF4-FFF2-40B4-BE49-F238E27FC236}">
-                <a16:creationId xmlns:a16="http://schemas.microsoft.com/office/drawing/2014/main" id="{5D7BA503-0A5F-640A-5189-E64276704030}"/>
+                <a16:creationId xmlns:a16="http://schemas.microsoft.com/office/drawing/2014/main" id="{C7C18519-91BF-DBFA-6481-0D853AA86F2E}"/>
               </a:ext>
             </a:extLst>
           </p:cNvPr>
@@ -2198,7 +2198,7 @@
           <p:cNvPr id="3" name="内容占位符 2">
             <a:extLst>
               <a:ext uri="{FF2B5EF4-FFF2-40B4-BE49-F238E27FC236}">
-                <a16:creationId xmlns:a16="http://schemas.microsoft.com/office/drawing/2014/main" id="{5568AF1C-3A15-AA2F-8513-9F4342CC1AE5}"/>
+                <a16:creationId xmlns:a16="http://schemas.microsoft.com/office/drawing/2014/main" id="{9F297308-D45D-74BF-222A-099F1E5B8113}"/>
               </a:ext>
             </a:extLst>
           </p:cNvPr>
@@ -2288,7 +2288,7 @@
           <p:cNvPr id="4" name="文本占位符 3">
             <a:extLst>
               <a:ext uri="{FF2B5EF4-FFF2-40B4-BE49-F238E27FC236}">
-                <a16:creationId xmlns:a16="http://schemas.microsoft.com/office/drawing/2014/main" id="{ABE8AA30-D711-F3A5-A13A-FE4E729350AE}"/>
+                <a16:creationId xmlns:a16="http://schemas.microsoft.com/office/drawing/2014/main" id="{691C8F03-37D3-6FC9-45DB-D89DAAD50ACF}"/>
               </a:ext>
             </a:extLst>
           </p:cNvPr>
@@ -2359,7 +2359,7 @@
           <p:cNvPr id="5" name="日期占位符 4">
             <a:extLst>
               <a:ext uri="{FF2B5EF4-FFF2-40B4-BE49-F238E27FC236}">
-                <a16:creationId xmlns:a16="http://schemas.microsoft.com/office/drawing/2014/main" id="{70A1AF57-7A96-E1D7-A109-B61E30267733}"/>
+                <a16:creationId xmlns:a16="http://schemas.microsoft.com/office/drawing/2014/main" id="{B9627DD2-597B-6052-A3DD-6160C82C5C23}"/>
               </a:ext>
             </a:extLst>
           </p:cNvPr>
@@ -2375,9 +2375,9 @@
           <a:bodyPr/>
           <a:lstStyle/>
           <a:p>
-            <a:fld id="{B4C0A41F-5E1D-4B08-9376-453926655FAB}" type="datetimeFigureOut">
+            <a:fld id="{2EA59CA5-E603-46AA-B66C-16837A232DBA}" type="datetimeFigureOut">
               <a:rPr lang="zh-CN" altLang="en-US" smtClean="0"/>
-              <a:t>2026/9/15</a:t>
+              <a:t>2026/9/17</a:t>
             </a:fld>
             <a:endParaRPr lang="zh-CN" altLang="en-US"/>
           </a:p>
@@ -2388,7 +2388,7 @@
           <p:cNvPr id="6" name="页脚占位符 5">
             <a:extLst>
               <a:ext uri="{FF2B5EF4-FFF2-40B4-BE49-F238E27FC236}">
-                <a16:creationId xmlns:a16="http://schemas.microsoft.com/office/drawing/2014/main" id="{90AA7651-A93C-9532-9A36-200B78098AE0}"/>
+                <a16:creationId xmlns:a16="http://schemas.microsoft.com/office/drawing/2014/main" id="{751C97E2-4C89-E1BC-8FEC-5DA7ED780266}"/>
               </a:ext>
             </a:extLst>
           </p:cNvPr>
@@ -2413,7 +2413,7 @@
           <p:cNvPr id="7" name="灯片编号占位符 6">
             <a:extLst>
               <a:ext uri="{FF2B5EF4-FFF2-40B4-BE49-F238E27FC236}">
-                <a16:creationId xmlns:a16="http://schemas.microsoft.com/office/drawing/2014/main" id="{A490BA0B-0E5C-80D5-ADCD-BDCFD101DCE6}"/>
+                <a16:creationId xmlns:a16="http://schemas.microsoft.com/office/drawing/2014/main" id="{D56D7303-414B-50D4-4204-212AB8B4F3D7}"/>
               </a:ext>
             </a:extLst>
           </p:cNvPr>
@@ -2429,7 +2429,7 @@
           <a:bodyPr/>
           <a:lstStyle/>
           <a:p>
-            <a:fld id="{7C925888-E23A-4AA5-A7F6-3D447E07EE5F}" type="slidenum">
+            <a:fld id="{F5AFB413-F331-4B80-9467-94C982ED185C}" type="slidenum">
               <a:rPr lang="zh-CN" altLang="en-US" smtClean="0"/>
               <a:t>‹#›</a:t>
             </a:fld>
@@ -2440,7 +2440,7 @@
     </p:spTree>
     <p:extLst>
       <p:ext uri="{BB962C8B-B14F-4D97-AF65-F5344CB8AC3E}">
-        <p14:creationId xmlns:p14="http://schemas.microsoft.com/office/powerpoint/2010/main" val="886472284"/>
+        <p14:creationId xmlns:p14="http://schemas.microsoft.com/office/powerpoint/2010/main" val="1319286952"/>
       </p:ext>
     </p:extLst>
   </p:cSld>
@@ -2472,7 +2472,7 @@
           <p:cNvPr id="2" name="标题 1">
             <a:extLst>
               <a:ext uri="{FF2B5EF4-FFF2-40B4-BE49-F238E27FC236}">
-                <a16:creationId xmlns:a16="http://schemas.microsoft.com/office/drawing/2014/main" id="{80FB79A2-812A-A5FF-3FD7-AEC642C400BC}"/>
+                <a16:creationId xmlns:a16="http://schemas.microsoft.com/office/drawing/2014/main" id="{C3DB228C-227B-8601-E41F-09E46B579288}"/>
               </a:ext>
             </a:extLst>
           </p:cNvPr>
@@ -2509,7 +2509,7 @@
           <p:cNvPr id="3" name="图片占位符 2">
             <a:extLst>
               <a:ext uri="{FF2B5EF4-FFF2-40B4-BE49-F238E27FC236}">
-                <a16:creationId xmlns:a16="http://schemas.microsoft.com/office/drawing/2014/main" id="{10F21F23-005E-CBEF-3870-B6FD6B662B3A}"/>
+                <a16:creationId xmlns:a16="http://schemas.microsoft.com/office/drawing/2014/main" id="{E777EA4E-7E3E-928C-92EB-2579C563DB97}"/>
               </a:ext>
             </a:extLst>
           </p:cNvPr>
@@ -2576,7 +2576,7 @@
           <p:cNvPr id="4" name="文本占位符 3">
             <a:extLst>
               <a:ext uri="{FF2B5EF4-FFF2-40B4-BE49-F238E27FC236}">
-                <a16:creationId xmlns:a16="http://schemas.microsoft.com/office/drawing/2014/main" id="{7AB4F719-6422-82C0-2C0C-D04A5CECC3A5}"/>
+                <a16:creationId xmlns:a16="http://schemas.microsoft.com/office/drawing/2014/main" id="{C2F4738E-6F65-9B03-6F0A-46072AD1DDF7}"/>
               </a:ext>
             </a:extLst>
           </p:cNvPr>
@@ -2647,7 +2647,7 @@
           <p:cNvPr id="5" name="日期占位符 4">
             <a:extLst>
               <a:ext uri="{FF2B5EF4-FFF2-40B4-BE49-F238E27FC236}">
-                <a16:creationId xmlns:a16="http://schemas.microsoft.com/office/drawing/2014/main" id="{79929E03-32E6-EC3C-B48C-CB5CAD415ABA}"/>
+                <a16:creationId xmlns:a16="http://schemas.microsoft.com/office/drawing/2014/main" id="{2F810EE2-04BD-9ABE-048E-A1FB85AF20FB}"/>
               </a:ext>
             </a:extLst>
           </p:cNvPr>
@@ -2663,9 +2663,9 @@
           <a:bodyPr/>
           <a:lstStyle/>
           <a:p>
-            <a:fld id="{B4C0A41F-5E1D-4B08-9376-453926655FAB}" type="datetimeFigureOut">
+            <a:fld id="{2EA59CA5-E603-46AA-B66C-16837A232DBA}" type="datetimeFigureOut">
               <a:rPr lang="zh-CN" altLang="en-US" smtClean="0"/>
-              <a:t>2026/9/15</a:t>
+              <a:t>2026/9/17</a:t>
             </a:fld>
             <a:endParaRPr lang="zh-CN" altLang="en-US"/>
           </a:p>
@@ -2676,7 +2676,7 @@
           <p:cNvPr id="6" name="页脚占位符 5">
             <a:extLst>
               <a:ext uri="{FF2B5EF4-FFF2-40B4-BE49-F238E27FC236}">
-                <a16:creationId xmlns:a16="http://schemas.microsoft.com/office/drawing/2014/main" id="{49A99D4F-E23B-1EF3-9749-5D55ECC94CA3}"/>
+                <a16:creationId xmlns:a16="http://schemas.microsoft.com/office/drawing/2014/main" id="{4F4E2137-C049-DBF6-2FAF-803BB3617378}"/>
               </a:ext>
             </a:extLst>
           </p:cNvPr>
@@ -2701,7 +2701,7 @@
           <p:cNvPr id="7" name="灯片编号占位符 6">
             <a:extLst>
               <a:ext uri="{FF2B5EF4-FFF2-40B4-BE49-F238E27FC236}">
-                <a16:creationId xmlns:a16="http://schemas.microsoft.com/office/drawing/2014/main" id="{F8683CAC-4F6E-EC32-03E0-F5ABD3589AAE}"/>
+                <a16:creationId xmlns:a16="http://schemas.microsoft.com/office/drawing/2014/main" id="{8EFA5C62-AA2C-A4AD-2D15-E11AF5811A54}"/>
               </a:ext>
             </a:extLst>
           </p:cNvPr>
@@ -2717,7 +2717,7 @@
           <a:bodyPr/>
           <a:lstStyle/>
           <a:p>
-            <a:fld id="{7C925888-E23A-4AA5-A7F6-3D447E07EE5F}" type="slidenum">
+            <a:fld id="{F5AFB413-F331-4B80-9467-94C982ED185C}" type="slidenum">
               <a:rPr lang="zh-CN" altLang="en-US" smtClean="0"/>
               <a:t>‹#›</a:t>
             </a:fld>
@@ -2728,7 +2728,7 @@
     </p:spTree>
     <p:extLst>
       <p:ext uri="{BB962C8B-B14F-4D97-AF65-F5344CB8AC3E}">
-        <p14:creationId xmlns:p14="http://schemas.microsoft.com/office/powerpoint/2010/main" val="734863409"/>
+        <p14:creationId xmlns:p14="http://schemas.microsoft.com/office/powerpoint/2010/main" val="402783159"/>
       </p:ext>
     </p:extLst>
   </p:cSld>
@@ -2765,7 +2765,7 @@
           <p:cNvPr id="2" name="标题占位符 1">
             <a:extLst>
               <a:ext uri="{FF2B5EF4-FFF2-40B4-BE49-F238E27FC236}">
-                <a16:creationId xmlns:a16="http://schemas.microsoft.com/office/drawing/2014/main" id="{32046B2B-608B-AEF1-9BC4-08C29F622E04}"/>
+                <a16:creationId xmlns:a16="http://schemas.microsoft.com/office/drawing/2014/main" id="{A9AD014D-E696-CD91-7D41-2B15CB8B70A9}"/>
               </a:ext>
             </a:extLst>
           </p:cNvPr>
@@ -2803,7 +2803,7 @@
           <p:cNvPr id="3" name="文本占位符 2">
             <a:extLst>
               <a:ext uri="{FF2B5EF4-FFF2-40B4-BE49-F238E27FC236}">
-                <a16:creationId xmlns:a16="http://schemas.microsoft.com/office/drawing/2014/main" id="{766EB5CF-CBBE-52D0-3280-71D85C01AD8A}"/>
+                <a16:creationId xmlns:a16="http://schemas.microsoft.com/office/drawing/2014/main" id="{4E164C04-2E9D-37A6-4F56-DA9737B77785}"/>
               </a:ext>
             </a:extLst>
           </p:cNvPr>
@@ -2870,7 +2870,7 @@
           <p:cNvPr id="4" name="日期占位符 3">
             <a:extLst>
               <a:ext uri="{FF2B5EF4-FFF2-40B4-BE49-F238E27FC236}">
-                <a16:creationId xmlns:a16="http://schemas.microsoft.com/office/drawing/2014/main" id="{8D362D5D-C395-4EE6-1463-E9AD42CD8FCD}"/>
+                <a16:creationId xmlns:a16="http://schemas.microsoft.com/office/drawing/2014/main" id="{60CF4072-44C5-1AF4-2379-E5B146D388C1}"/>
               </a:ext>
             </a:extLst>
           </p:cNvPr>
@@ -2904,9 +2904,9 @@
             </a:lvl1pPr>
           </a:lstStyle>
           <a:p>
-            <a:fld id="{B4C0A41F-5E1D-4B08-9376-453926655FAB}" type="datetimeFigureOut">
+            <a:fld id="{2EA59CA5-E603-46AA-B66C-16837A232DBA}" type="datetimeFigureOut">
               <a:rPr lang="zh-CN" altLang="en-US" smtClean="0"/>
-              <a:t>2026/9/15</a:t>
+              <a:t>2026/9/17</a:t>
             </a:fld>
             <a:endParaRPr lang="zh-CN" altLang="en-US"/>
           </a:p>
@@ -2917,7 +2917,7 @@
           <p:cNvPr id="5" name="页脚占位符 4">
             <a:extLst>
               <a:ext uri="{FF2B5EF4-FFF2-40B4-BE49-F238E27FC236}">
-                <a16:creationId xmlns:a16="http://schemas.microsoft.com/office/drawing/2014/main" id="{43C5967F-7571-D4E0-1D58-91D7EAF1EB06}"/>
+                <a16:creationId xmlns:a16="http://schemas.microsoft.com/office/drawing/2014/main" id="{2BEB8499-D37B-A712-2F24-671BF9F06B9B}"/>
               </a:ext>
             </a:extLst>
           </p:cNvPr>
@@ -2960,7 +2960,7 @@
           <p:cNvPr id="6" name="灯片编号占位符 5">
             <a:extLst>
               <a:ext uri="{FF2B5EF4-FFF2-40B4-BE49-F238E27FC236}">
-                <a16:creationId xmlns:a16="http://schemas.microsoft.com/office/drawing/2014/main" id="{6296E465-E75B-4C35-B392-7C0E00B5943B}"/>
+                <a16:creationId xmlns:a16="http://schemas.microsoft.com/office/drawing/2014/main" id="{039D8653-FFFB-D654-35A5-70CCE950F01E}"/>
               </a:ext>
             </a:extLst>
           </p:cNvPr>
@@ -2994,7 +2994,7 @@
             </a:lvl1pPr>
           </a:lstStyle>
           <a:p>
-            <a:fld id="{7C925888-E23A-4AA5-A7F6-3D447E07EE5F}" type="slidenum">
+            <a:fld id="{F5AFB413-F331-4B80-9467-94C982ED185C}" type="slidenum">
               <a:rPr lang="zh-CN" altLang="en-US" smtClean="0"/>
               <a:t>‹#›</a:t>
             </a:fld>
@@ -3005,7 +3005,7 @@
     </p:spTree>
     <p:extLst>
       <p:ext uri="{BB962C8B-B14F-4D97-AF65-F5344CB8AC3E}">
-        <p14:creationId xmlns:p14="http://schemas.microsoft.com/office/powerpoint/2010/main" val="3750961601"/>
+        <p14:creationId xmlns:p14="http://schemas.microsoft.com/office/powerpoint/2010/main" val="3695369394"/>
       </p:ext>
     </p:extLst>
   </p:cSld>
@@ -3328,7 +3328,7 @@
           <p:cNvPr id="3" name="LogoLeft">
             <a:extLst>
               <a:ext uri="{FF2B5EF4-FFF2-40B4-BE49-F238E27FC236}">
-                <a16:creationId xmlns:a16="http://schemas.microsoft.com/office/drawing/2014/main" id="{51C397AE-8C1E-F121-53AE-4F878B805A31}"/>
+                <a16:creationId xmlns:a16="http://schemas.microsoft.com/office/drawing/2014/main" id="{7215CEAB-C7CA-6AC7-38B9-A1DE5A74C6B2}"/>
               </a:ext>
             </a:extLst>
           </p:cNvPr>
@@ -3364,7 +3364,7 @@
           <p:cNvPr id="4" name="CoverSession">
             <a:extLst>
               <a:ext uri="{FF2B5EF4-FFF2-40B4-BE49-F238E27FC236}">
-                <a16:creationId xmlns:a16="http://schemas.microsoft.com/office/drawing/2014/main" id="{3FA86DC6-9041-3D06-2D08-30AB7EE72DEA}"/>
+                <a16:creationId xmlns:a16="http://schemas.microsoft.com/office/drawing/2014/main" id="{5167009F-BDA3-5A46-1125-E219E5090B5A}"/>
               </a:ext>
             </a:extLst>
           </p:cNvPr>
@@ -3374,7 +3374,7 @@
         <p:spPr>
           <a:xfrm>
             <a:off x="4191000" y="203200"/>
-            <a:ext cx="3810000" cy="584775"/>
+            <a:ext cx="3810000" cy="631711"/>
           </a:xfrm>
           <a:prstGeom prst="rect">
             <a:avLst/>
@@ -3387,13 +3387,21 @@
           </a:bodyPr>
           <a:lstStyle/>
           <a:p>
-            <a:pPr algn="ctr"/>
+            <a:pPr algn="ctr">
+              <a:lnSpc>
+                <a:spcPct val="120000"/>
+              </a:lnSpc>
+              <a:spcAft>
+                <a:spcPts val="768"/>
+              </a:spcAft>
+            </a:pPr>
             <a:r>
               <a:rPr lang="en-US" altLang="zh-CN" sz="3200" b="1">
                 <a:solidFill>
                   <a:srgbClr val="000000"/>
                 </a:solidFill>
-                <a:latin typeface="Calibri" panose="020F0502020204030204" pitchFamily="34" charset="0"/>
+                <a:latin typeface="Times New Roman" panose="02020603050405020304" pitchFamily="18" charset="0"/>
+                <a:ea typeface="微软雅黑" panose="020B0503020204020204" pitchFamily="34" charset="-122"/>
               </a:rPr>
               <a:t>RTu1A-3</a:t>
             </a:r>
@@ -3401,7 +3409,8 @@
               <a:solidFill>
                 <a:srgbClr val="000000"/>
               </a:solidFill>
-              <a:latin typeface="Calibri" panose="020F0502020204030204" pitchFamily="34" charset="0"/>
+              <a:latin typeface="Times New Roman" panose="02020603050405020304" pitchFamily="18" charset="0"/>
+              <a:ea typeface="微软雅黑" panose="020B0503020204020204" pitchFamily="34" charset="-122"/>
             </a:endParaRPr>
           </a:p>
         </p:txBody>
@@ -3411,7 +3420,7 @@
           <p:cNvPr id="5" name="CoverTitle">
             <a:extLst>
               <a:ext uri="{FF2B5EF4-FFF2-40B4-BE49-F238E27FC236}">
-                <a16:creationId xmlns:a16="http://schemas.microsoft.com/office/drawing/2014/main" id="{841938A4-BCD4-63E1-0B87-7E8565D0ABE8}"/>
+                <a16:creationId xmlns:a16="http://schemas.microsoft.com/office/drawing/2014/main" id="{1F023869-6D19-3201-B258-5C03E15C07F9}"/>
               </a:ext>
             </a:extLst>
           </p:cNvPr>
@@ -3421,7 +3430,7 @@
         <p:spPr>
           <a:xfrm>
             <a:off x="1016000" y="1524000"/>
-            <a:ext cx="10160000" cy="1938992"/>
+            <a:ext cx="10160000" cy="2243884"/>
           </a:xfrm>
           <a:prstGeom prst="rect">
             <a:avLst/>
@@ -3434,13 +3443,21 @@
           </a:bodyPr>
           <a:lstStyle/>
           <a:p>
-            <a:pPr algn="ctr"/>
+            <a:pPr algn="ctr">
+              <a:lnSpc>
+                <a:spcPct val="120000"/>
+              </a:lnSpc>
+              <a:spcAft>
+                <a:spcPts val="960"/>
+              </a:spcAft>
+            </a:pPr>
             <a:r>
               <a:rPr lang="en-US" altLang="zh-CN" sz="4000" b="1">
                 <a:solidFill>
                   <a:srgbClr val="000000"/>
                 </a:solidFill>
-                <a:latin typeface="Calibri" panose="020F0502020204030204" pitchFamily="34" charset="0"/>
+                <a:latin typeface="Times New Roman" panose="02020603050405020304" pitchFamily="18" charset="0"/>
+                <a:ea typeface="微软雅黑" panose="020B0503020204020204" pitchFamily="34" charset="-122"/>
               </a:rPr>
               <a:t>A Capacitor-Assisting Triple-Winding Transformer LNA with 0.8-1.5 dB NF and 6-12 GHz BW in 130 nm SOI CMOS</a:t>
             </a:r>
@@ -3448,7 +3465,8 @@
               <a:solidFill>
                 <a:srgbClr val="000000"/>
               </a:solidFill>
-              <a:latin typeface="Calibri" panose="020F0502020204030204" pitchFamily="34" charset="0"/>
+              <a:latin typeface="Times New Roman" panose="02020603050405020304" pitchFamily="18" charset="0"/>
+              <a:ea typeface="微软雅黑" panose="020B0503020204020204" pitchFamily="34" charset="-122"/>
             </a:endParaRPr>
           </a:p>
         </p:txBody>
@@ -3458,7 +3476,7 @@
           <p:cNvPr id="6" name="CoverAuthors">
             <a:extLst>
               <a:ext uri="{FF2B5EF4-FFF2-40B4-BE49-F238E27FC236}">
-                <a16:creationId xmlns:a16="http://schemas.microsoft.com/office/drawing/2014/main" id="{31639594-C527-5272-D7C8-520E76C050B5}"/>
+                <a16:creationId xmlns:a16="http://schemas.microsoft.com/office/drawing/2014/main" id="{3E69841F-7329-5FDE-E983-B695056DBFC1}"/>
               </a:ext>
             </a:extLst>
           </p:cNvPr>
@@ -3468,7 +3486,7 @@
         <p:spPr>
           <a:xfrm>
             <a:off x="1905000" y="4064000"/>
-            <a:ext cx="8382000" cy="461665"/>
+            <a:ext cx="8382000" cy="497765"/>
           </a:xfrm>
           <a:prstGeom prst="rect">
             <a:avLst/>
@@ -3481,13 +3499,21 @@
           </a:bodyPr>
           <a:lstStyle/>
           <a:p>
-            <a:pPr algn="ctr"/>
+            <a:pPr algn="ctr">
+              <a:lnSpc>
+                <a:spcPct val="120000"/>
+              </a:lnSpc>
+              <a:spcAft>
+                <a:spcPts val="576"/>
+              </a:spcAft>
+            </a:pPr>
             <a:r>
               <a:rPr lang="en-US" altLang="zh-CN" sz="2400" b="1">
                 <a:solidFill>
                   <a:srgbClr val="000000"/>
                 </a:solidFill>
-                <a:latin typeface="Franklin Gothic Book" panose="020B0503020102020204" pitchFamily="34" charset="0"/>
+                <a:latin typeface="Times New Roman" panose="02020603050405020304" pitchFamily="18" charset="0"/>
+                <a:ea typeface="微软雅黑" panose="020B0503020204020204" pitchFamily="34" charset="-122"/>
               </a:rPr>
               <a:t>T. Zou  (</a:t>
             </a:r>
@@ -3496,7 +3522,8 @@
                 <a:solidFill>
                   <a:srgbClr val="000000"/>
                 </a:solidFill>
-                <a:latin typeface="Franklin Gothic Book" panose="020B0503020102020204" pitchFamily="34" charset="0"/>
+                <a:latin typeface="Times New Roman" panose="02020603050405020304" pitchFamily="18" charset="0"/>
+                <a:ea typeface="微软雅黑" panose="020B0503020204020204" pitchFamily="34" charset="-122"/>
               </a:rPr>
               <a:t>作者名单见论文首页 </a:t>
             </a:r>
@@ -3505,7 +3532,8 @@
                 <a:solidFill>
                   <a:srgbClr val="000000"/>
                 </a:solidFill>
-                <a:latin typeface="Franklin Gothic Book" panose="020B0503020102020204" pitchFamily="34" charset="0"/>
+                <a:latin typeface="Times New Roman" panose="02020603050405020304" pitchFamily="18" charset="0"/>
+                <a:ea typeface="微软雅黑" panose="020B0503020204020204" pitchFamily="34" charset="-122"/>
               </a:rPr>
               <a:t>- MVP </a:t>
             </a:r>
@@ -3514,7 +3542,8 @@
                 <a:solidFill>
                   <a:srgbClr val="000000"/>
                 </a:solidFill>
-                <a:latin typeface="Franklin Gothic Book" panose="020B0503020102020204" pitchFamily="34" charset="0"/>
+                <a:latin typeface="Times New Roman" panose="02020603050405020304" pitchFamily="18" charset="0"/>
+                <a:ea typeface="微软雅黑" panose="020B0503020204020204" pitchFamily="34" charset="-122"/>
               </a:rPr>
               <a:t>占位</a:t>
             </a:r>
@@ -3523,7 +3552,8 @@
                 <a:solidFill>
                   <a:srgbClr val="000000"/>
                 </a:solidFill>
-                <a:latin typeface="Franklin Gothic Book" panose="020B0503020102020204" pitchFamily="34" charset="0"/>
+                <a:latin typeface="Times New Roman" panose="02020603050405020304" pitchFamily="18" charset="0"/>
+                <a:ea typeface="微软雅黑" panose="020B0503020204020204" pitchFamily="34" charset="-122"/>
               </a:rPr>
               <a:t>)</a:t>
             </a:r>
@@ -3531,7 +3561,8 @@
               <a:solidFill>
                 <a:srgbClr val="000000"/>
               </a:solidFill>
-              <a:latin typeface="Franklin Gothic Book" panose="020B0503020102020204" pitchFamily="34" charset="0"/>
+              <a:latin typeface="Times New Roman" panose="02020603050405020304" pitchFamily="18" charset="0"/>
+              <a:ea typeface="微软雅黑" panose="020B0503020204020204" pitchFamily="34" charset="-122"/>
             </a:endParaRPr>
           </a:p>
         </p:txBody>
@@ -3541,7 +3572,7 @@
           <p:cNvPr id="7" name="CoverAffil">
             <a:extLst>
               <a:ext uri="{FF2B5EF4-FFF2-40B4-BE49-F238E27FC236}">
-                <a16:creationId xmlns:a16="http://schemas.microsoft.com/office/drawing/2014/main" id="{ADC03DB0-C6C9-A205-1E10-96926FC19F14}"/>
+                <a16:creationId xmlns:a16="http://schemas.microsoft.com/office/drawing/2014/main" id="{7852E0DC-721D-21A7-1A00-7574CBCCAE43}"/>
               </a:ext>
             </a:extLst>
           </p:cNvPr>
@@ -3551,7 +3582,7 @@
         <p:spPr>
           <a:xfrm>
             <a:off x="1905000" y="4699000"/>
-            <a:ext cx="8382000" cy="400110"/>
+            <a:ext cx="8382000" cy="430182"/>
           </a:xfrm>
           <a:prstGeom prst="rect">
             <a:avLst/>
@@ -3564,13 +3595,21 @@
           </a:bodyPr>
           <a:lstStyle/>
           <a:p>
-            <a:pPr algn="ctr"/>
+            <a:pPr algn="ctr">
+              <a:lnSpc>
+                <a:spcPct val="120000"/>
+              </a:lnSpc>
+              <a:spcAft>
+                <a:spcPts val="480"/>
+              </a:spcAft>
+            </a:pPr>
             <a:r>
               <a:rPr lang="en-US" altLang="zh-CN" sz="2000" b="1">
                 <a:solidFill>
                   <a:srgbClr val="000000"/>
                 </a:solidFill>
-                <a:latin typeface="Franklin Gothic Book" panose="020B0503020102020204" pitchFamily="34" charset="0"/>
+                <a:latin typeface="Times New Roman" panose="02020603050405020304" pitchFamily="18" charset="0"/>
+                <a:ea typeface="微软雅黑" panose="020B0503020204020204" pitchFamily="34" charset="-122"/>
               </a:rPr>
               <a:t>Affiliation: see paper first page (</a:t>
             </a:r>
@@ -3579,7 +3618,8 @@
                 <a:solidFill>
                   <a:srgbClr val="000000"/>
                 </a:solidFill>
-                <a:latin typeface="Franklin Gothic Book" panose="020B0503020102020204" pitchFamily="34" charset="0"/>
+                <a:latin typeface="Times New Roman" panose="02020603050405020304" pitchFamily="18" charset="0"/>
+                <a:ea typeface="微软雅黑" panose="020B0503020204020204" pitchFamily="34" charset="-122"/>
               </a:rPr>
               <a:t>待补充</a:t>
             </a:r>
@@ -3588,7 +3628,8 @@
                 <a:solidFill>
                   <a:srgbClr val="000000"/>
                 </a:solidFill>
-                <a:latin typeface="Franklin Gothic Book" panose="020B0503020102020204" pitchFamily="34" charset="0"/>
+                <a:latin typeface="Times New Roman" panose="02020603050405020304" pitchFamily="18" charset="0"/>
+                <a:ea typeface="微软雅黑" panose="020B0503020204020204" pitchFamily="34" charset="-122"/>
               </a:rPr>
               <a:t>)</a:t>
             </a:r>
@@ -3596,7 +3637,8 @@
               <a:solidFill>
                 <a:srgbClr val="000000"/>
               </a:solidFill>
-              <a:latin typeface="Franklin Gothic Book" panose="020B0503020102020204" pitchFamily="34" charset="0"/>
+              <a:latin typeface="Times New Roman" panose="02020603050405020304" pitchFamily="18" charset="0"/>
+              <a:ea typeface="微软雅黑" panose="020B0503020204020204" pitchFamily="34" charset="-122"/>
             </a:endParaRPr>
           </a:p>
         </p:txBody>
@@ -3606,7 +3648,7 @@
           <p:cNvPr id="9" name="FooterBand">
             <a:extLst>
               <a:ext uri="{FF2B5EF4-FFF2-40B4-BE49-F238E27FC236}">
-                <a16:creationId xmlns:a16="http://schemas.microsoft.com/office/drawing/2014/main" id="{C05C1E4B-E212-BDB7-D5BB-9A35FCF2F5AE}"/>
+                <a16:creationId xmlns:a16="http://schemas.microsoft.com/office/drawing/2014/main" id="{E6EE808F-FF54-EC71-FCEE-DF1A7BAF6B7A}"/>
               </a:ext>
             </a:extLst>
           </p:cNvPr>
@@ -3642,7 +3684,7 @@
           <p:cNvPr id="10" name="PageNo">
             <a:extLst>
               <a:ext uri="{FF2B5EF4-FFF2-40B4-BE49-F238E27FC236}">
-                <a16:creationId xmlns:a16="http://schemas.microsoft.com/office/drawing/2014/main" id="{D9D60A50-BC13-487F-6C9F-A8E72D97CDB2}"/>
+                <a16:creationId xmlns:a16="http://schemas.microsoft.com/office/drawing/2014/main" id="{DF7C8C48-A8CB-45D2-5E2C-D77029767724}"/>
               </a:ext>
             </a:extLst>
           </p:cNvPr>
@@ -3652,7 +3694,7 @@
         <p:spPr>
           <a:xfrm>
             <a:off x="5588000" y="6426200"/>
-            <a:ext cx="1016000" cy="400110"/>
+            <a:ext cx="1016000" cy="429413"/>
           </a:xfrm>
           <a:prstGeom prst="rect">
             <a:avLst/>
@@ -3665,13 +3707,21 @@
           </a:bodyPr>
           <a:lstStyle/>
           <a:p>
-            <a:pPr algn="ctr"/>
+            <a:pPr algn="ctr">
+              <a:lnSpc>
+                <a:spcPct val="120000"/>
+              </a:lnSpc>
+              <a:spcAft>
+                <a:spcPts val="480"/>
+              </a:spcAft>
+            </a:pPr>
             <a:r>
               <a:rPr lang="en-US" altLang="zh-CN" sz="2000">
                 <a:solidFill>
                   <a:srgbClr val="000000"/>
                 </a:solidFill>
-                <a:latin typeface="Calibri" panose="020F0502020204030204" pitchFamily="34" charset="0"/>
+                <a:latin typeface="Times New Roman" panose="02020603050405020304" pitchFamily="18" charset="0"/>
+                <a:ea typeface="微软雅黑" panose="020B0503020204020204" pitchFamily="34" charset="-122"/>
               </a:rPr>
               <a:t>0</a:t>
             </a:r>
@@ -3679,7 +3729,8 @@
               <a:solidFill>
                 <a:srgbClr val="000000"/>
               </a:solidFill>
-              <a:latin typeface="Calibri" panose="020F0502020204030204" pitchFamily="34" charset="0"/>
+              <a:latin typeface="Times New Roman" panose="02020603050405020304" pitchFamily="18" charset="0"/>
+              <a:ea typeface="微软雅黑" panose="020B0503020204020204" pitchFamily="34" charset="-122"/>
             </a:endParaRPr>
           </a:p>
         </p:txBody>
@@ -3689,7 +3740,7 @@
           <p:cNvPr id="11" name="SessionId">
             <a:extLst>
               <a:ext uri="{FF2B5EF4-FFF2-40B4-BE49-F238E27FC236}">
-                <a16:creationId xmlns:a16="http://schemas.microsoft.com/office/drawing/2014/main" id="{F34007C0-603D-825D-5E6D-DD3B7DAB542B}"/>
+                <a16:creationId xmlns:a16="http://schemas.microsoft.com/office/drawing/2014/main" id="{E117C072-BBE5-C6C9-52F5-6B4B75EF76BE}"/>
               </a:ext>
             </a:extLst>
           </p:cNvPr>
@@ -3699,7 +3750,7 @@
         <p:spPr>
           <a:xfrm>
             <a:off x="9906000" y="6451600"/>
-            <a:ext cx="2159000" cy="307777"/>
+            <a:ext cx="2159000" cy="328360"/>
           </a:xfrm>
           <a:prstGeom prst="rect">
             <a:avLst/>
@@ -3712,13 +3763,21 @@
           </a:bodyPr>
           <a:lstStyle/>
           <a:p>
-            <a:pPr algn="ctr"/>
+            <a:pPr algn="ctr">
+              <a:lnSpc>
+                <a:spcPct val="120000"/>
+              </a:lnSpc>
+              <a:spcAft>
+                <a:spcPts val="336"/>
+              </a:spcAft>
+            </a:pPr>
             <a:r>
               <a:rPr lang="en-US" altLang="zh-CN" sz="1400">
                 <a:solidFill>
                   <a:srgbClr val="000000"/>
                 </a:solidFill>
-                <a:latin typeface="Calibri" panose="020F0502020204030204" pitchFamily="34" charset="0"/>
+                <a:latin typeface="Times New Roman" panose="02020603050405020304" pitchFamily="18" charset="0"/>
+                <a:ea typeface="微软雅黑" panose="020B0503020204020204" pitchFamily="34" charset="-122"/>
               </a:rPr>
               <a:t>RTu1A-3</a:t>
             </a:r>
@@ -3726,7 +3785,8 @@
               <a:solidFill>
                 <a:srgbClr val="000000"/>
               </a:solidFill>
-              <a:latin typeface="Calibri" panose="020F0502020204030204" pitchFamily="34" charset="0"/>
+              <a:latin typeface="Times New Roman" panose="02020603050405020304" pitchFamily="18" charset="0"/>
+              <a:ea typeface="微软雅黑" panose="020B0503020204020204" pitchFamily="34" charset="-122"/>
             </a:endParaRPr>
           </a:p>
         </p:txBody>
@@ -3734,7 +3794,7 @@
     </p:spTree>
     <p:extLst>
       <p:ext uri="{BB962C8B-B14F-4D97-AF65-F5344CB8AC3E}">
-        <p14:creationId xmlns:p14="http://schemas.microsoft.com/office/powerpoint/2010/main" val="847776602"/>
+        <p14:creationId xmlns:p14="http://schemas.microsoft.com/office/powerpoint/2010/main" val="728059402"/>
       </p:ext>
     </p:extLst>
   </p:cSld>
@@ -3766,7 +3826,7 @@
           <p:cNvPr id="3" name="LogoLeft">
             <a:extLst>
               <a:ext uri="{FF2B5EF4-FFF2-40B4-BE49-F238E27FC236}">
-                <a16:creationId xmlns:a16="http://schemas.microsoft.com/office/drawing/2014/main" id="{4CA0A716-2BF0-4374-A825-679C8CA2B815}"/>
+                <a16:creationId xmlns:a16="http://schemas.microsoft.com/office/drawing/2014/main" id="{97C5F169-B8AE-84C9-5627-4B028DCD7473}"/>
               </a:ext>
             </a:extLst>
           </p:cNvPr>
@@ -3802,7 +3862,7 @@
           <p:cNvPr id="4" name="Title">
             <a:extLst>
               <a:ext uri="{FF2B5EF4-FFF2-40B4-BE49-F238E27FC236}">
-                <a16:creationId xmlns:a16="http://schemas.microsoft.com/office/drawing/2014/main" id="{1BB74906-25FE-4328-162B-42850EBA2FA8}"/>
+                <a16:creationId xmlns:a16="http://schemas.microsoft.com/office/drawing/2014/main" id="{FA196DD4-DA57-D2AC-F8ED-739DE0DAC8BD}"/>
               </a:ext>
             </a:extLst>
           </p:cNvPr>
@@ -3812,7 +3872,7 @@
         <p:spPr>
           <a:xfrm>
             <a:off x="508000" y="114300"/>
-            <a:ext cx="11176000" cy="769441"/>
+            <a:ext cx="11176000" cy="834011"/>
           </a:xfrm>
           <a:prstGeom prst="rect">
             <a:avLst/>
@@ -3825,13 +3885,21 @@
           </a:bodyPr>
           <a:lstStyle/>
           <a:p>
-            <a:pPr algn="ctr"/>
+            <a:pPr algn="ctr">
+              <a:lnSpc>
+                <a:spcPct val="120000"/>
+              </a:lnSpc>
+              <a:spcAft>
+                <a:spcPts val="1056"/>
+              </a:spcAft>
+            </a:pPr>
             <a:r>
               <a:rPr lang="en-US" altLang="zh-CN" sz="4400">
                 <a:solidFill>
                   <a:srgbClr val="000000"/>
                 </a:solidFill>
-                <a:latin typeface="Franklin Gothic Book" panose="020B0503020102020204" pitchFamily="34" charset="0"/>
+                <a:latin typeface="Times New Roman" panose="02020603050405020304" pitchFamily="18" charset="0"/>
+                <a:ea typeface="微软雅黑" panose="020B0503020204020204" pitchFamily="34" charset="-122"/>
               </a:rPr>
               <a:t>Outline</a:t>
             </a:r>
@@ -3839,7 +3907,8 @@
               <a:solidFill>
                 <a:srgbClr val="000000"/>
               </a:solidFill>
-              <a:latin typeface="Franklin Gothic Book" panose="020B0503020102020204" pitchFamily="34" charset="0"/>
+              <a:latin typeface="Times New Roman" panose="02020603050405020304" pitchFamily="18" charset="0"/>
+              <a:ea typeface="微软雅黑" panose="020B0503020204020204" pitchFamily="34" charset="-122"/>
             </a:endParaRPr>
           </a:p>
         </p:txBody>
@@ -3849,7 +3918,7 @@
           <p:cNvPr id="5" name="OutlineBullets">
             <a:extLst>
               <a:ext uri="{FF2B5EF4-FFF2-40B4-BE49-F238E27FC236}">
-                <a16:creationId xmlns:a16="http://schemas.microsoft.com/office/drawing/2014/main" id="{80BB8366-CB39-FC10-D232-A6CE0F664C0A}"/>
+                <a16:creationId xmlns:a16="http://schemas.microsoft.com/office/drawing/2014/main" id="{9C90DF33-E7D5-19D9-BE71-5180CDE5F816}"/>
               </a:ext>
             </a:extLst>
           </p:cNvPr>
@@ -3859,7 +3928,7 @@
         <p:spPr>
           <a:xfrm>
             <a:off x="927100" y="1778000"/>
-            <a:ext cx="8890000" cy="1569660"/>
+            <a:ext cx="8890000" cy="1813573"/>
           </a:xfrm>
           <a:prstGeom prst="rect">
             <a:avLst/>
@@ -3872,12 +3941,21 @@
           </a:bodyPr>
           <a:lstStyle/>
           <a:p>
+            <a:pPr>
+              <a:lnSpc>
+                <a:spcPct val="120000"/>
+              </a:lnSpc>
+              <a:spcAft>
+                <a:spcPts val="768"/>
+              </a:spcAft>
+            </a:pPr>
             <a:r>
               <a:rPr lang="en-US" altLang="zh-CN" sz="3200">
                 <a:solidFill>
                   <a:srgbClr val="000000"/>
                 </a:solidFill>
-                <a:latin typeface="Franklin Gothic Book" panose="020B0503020102020204" pitchFamily="34" charset="0"/>
+                <a:latin typeface="Times New Roman" panose="02020603050405020304" pitchFamily="18" charset="0"/>
+                <a:ea typeface="微软雅黑" panose="020B0503020204020204" pitchFamily="34" charset="-122"/>
               </a:rPr>
               <a:t>•  Background &amp; Challenges</a:t>
             </a:r>
@@ -3886,7 +3964,8 @@
                 <a:solidFill>
                   <a:srgbClr val="000000"/>
                 </a:solidFill>
-                <a:latin typeface="Franklin Gothic Book" panose="020B0503020102020204" pitchFamily="34" charset="0"/>
+                <a:latin typeface="Times New Roman" panose="02020603050405020304" pitchFamily="18" charset="0"/>
+                <a:ea typeface="微软雅黑" panose="020B0503020204020204" pitchFamily="34" charset="-122"/>
               </a:rPr>
             </a:br>
             <a:r>
@@ -3894,7 +3973,8 @@
                 <a:solidFill>
                   <a:srgbClr val="000000"/>
                 </a:solidFill>
-                <a:latin typeface="Franklin Gothic Book" panose="020B0503020102020204" pitchFamily="34" charset="0"/>
+                <a:latin typeface="Times New Roman" panose="02020603050405020304" pitchFamily="18" charset="0"/>
+                <a:ea typeface="微软雅黑" panose="020B0503020204020204" pitchFamily="34" charset="-122"/>
               </a:rPr>
               <a:t>•  Proposed Triple-Winding Transformer LNA</a:t>
             </a:r>
@@ -3903,7 +3983,8 @@
                 <a:solidFill>
                   <a:srgbClr val="000000"/>
                 </a:solidFill>
-                <a:latin typeface="Franklin Gothic Book" panose="020B0503020102020204" pitchFamily="34" charset="0"/>
+                <a:latin typeface="Times New Roman" panose="02020603050405020304" pitchFamily="18" charset="0"/>
+                <a:ea typeface="微软雅黑" panose="020B0503020204020204" pitchFamily="34" charset="-122"/>
               </a:rPr>
             </a:br>
             <a:r>
@@ -3911,7 +3992,8 @@
                 <a:solidFill>
                   <a:srgbClr val="000000"/>
                 </a:solidFill>
-                <a:latin typeface="Franklin Gothic Book" panose="020B0503020102020204" pitchFamily="34" charset="0"/>
+                <a:latin typeface="Times New Roman" panose="02020603050405020304" pitchFamily="18" charset="0"/>
+                <a:ea typeface="微软雅黑" panose="020B0503020204020204" pitchFamily="34" charset="-122"/>
               </a:rPr>
               <a:t>•  Measurement Results</a:t>
             </a:r>
@@ -3919,7 +4001,8 @@
               <a:solidFill>
                 <a:srgbClr val="000000"/>
               </a:solidFill>
-              <a:latin typeface="Franklin Gothic Book" panose="020B0503020102020204" pitchFamily="34" charset="0"/>
+              <a:latin typeface="Times New Roman" panose="02020603050405020304" pitchFamily="18" charset="0"/>
+              <a:ea typeface="微软雅黑" panose="020B0503020204020204" pitchFamily="34" charset="-122"/>
             </a:endParaRPr>
           </a:p>
         </p:txBody>
@@ -3929,7 +4012,7 @@
           <p:cNvPr id="7" name="FooterBand">
             <a:extLst>
               <a:ext uri="{FF2B5EF4-FFF2-40B4-BE49-F238E27FC236}">
-                <a16:creationId xmlns:a16="http://schemas.microsoft.com/office/drawing/2014/main" id="{A9094532-E6F6-E51E-5380-5C4A3C3D62C7}"/>
+                <a16:creationId xmlns:a16="http://schemas.microsoft.com/office/drawing/2014/main" id="{30E94C69-7479-2E5D-2C1D-6DDE607B34EC}"/>
               </a:ext>
             </a:extLst>
           </p:cNvPr>
@@ -3965,7 +4048,7 @@
           <p:cNvPr id="8" name="PageNo">
             <a:extLst>
               <a:ext uri="{FF2B5EF4-FFF2-40B4-BE49-F238E27FC236}">
-                <a16:creationId xmlns:a16="http://schemas.microsoft.com/office/drawing/2014/main" id="{C23A6888-9399-7732-5D60-DECAFF7D43A8}"/>
+                <a16:creationId xmlns:a16="http://schemas.microsoft.com/office/drawing/2014/main" id="{61B24CB8-E2F3-DCBF-E485-1A0274EF8E1E}"/>
               </a:ext>
             </a:extLst>
           </p:cNvPr>
@@ -3975,7 +4058,7 @@
         <p:spPr>
           <a:xfrm>
             <a:off x="5588000" y="6426200"/>
-            <a:ext cx="1016000" cy="400110"/>
+            <a:ext cx="1016000" cy="429413"/>
           </a:xfrm>
           <a:prstGeom prst="rect">
             <a:avLst/>
@@ -3988,13 +4071,21 @@
           </a:bodyPr>
           <a:lstStyle/>
           <a:p>
-            <a:pPr algn="ctr"/>
+            <a:pPr algn="ctr">
+              <a:lnSpc>
+                <a:spcPct val="120000"/>
+              </a:lnSpc>
+              <a:spcAft>
+                <a:spcPts val="480"/>
+              </a:spcAft>
+            </a:pPr>
             <a:r>
               <a:rPr lang="en-US" altLang="zh-CN" sz="2000">
                 <a:solidFill>
                   <a:srgbClr val="000000"/>
                 </a:solidFill>
-                <a:latin typeface="Calibri" panose="020F0502020204030204" pitchFamily="34" charset="0"/>
+                <a:latin typeface="Times New Roman" panose="02020603050405020304" pitchFamily="18" charset="0"/>
+                <a:ea typeface="微软雅黑" panose="020B0503020204020204" pitchFamily="34" charset="-122"/>
               </a:rPr>
               <a:t>1</a:t>
             </a:r>
@@ -4002,7 +4093,8 @@
               <a:solidFill>
                 <a:srgbClr val="000000"/>
               </a:solidFill>
-              <a:latin typeface="Calibri" panose="020F0502020204030204" pitchFamily="34" charset="0"/>
+              <a:latin typeface="Times New Roman" panose="02020603050405020304" pitchFamily="18" charset="0"/>
+              <a:ea typeface="微软雅黑" panose="020B0503020204020204" pitchFamily="34" charset="-122"/>
             </a:endParaRPr>
           </a:p>
         </p:txBody>
@@ -4012,7 +4104,7 @@
           <p:cNvPr id="9" name="SessionId">
             <a:extLst>
               <a:ext uri="{FF2B5EF4-FFF2-40B4-BE49-F238E27FC236}">
-                <a16:creationId xmlns:a16="http://schemas.microsoft.com/office/drawing/2014/main" id="{19D62491-AA7A-3154-861E-6ABA876CA088}"/>
+                <a16:creationId xmlns:a16="http://schemas.microsoft.com/office/drawing/2014/main" id="{49932A76-C731-2FAA-AD9E-3784A07D75EB}"/>
               </a:ext>
             </a:extLst>
           </p:cNvPr>
@@ -4022,7 +4114,7 @@
         <p:spPr>
           <a:xfrm>
             <a:off x="9906000" y="6451600"/>
-            <a:ext cx="2159000" cy="307777"/>
+            <a:ext cx="2159000" cy="328360"/>
           </a:xfrm>
           <a:prstGeom prst="rect">
             <a:avLst/>
@@ -4035,13 +4127,21 @@
           </a:bodyPr>
           <a:lstStyle/>
           <a:p>
-            <a:pPr algn="ctr"/>
+            <a:pPr algn="ctr">
+              <a:lnSpc>
+                <a:spcPct val="120000"/>
+              </a:lnSpc>
+              <a:spcAft>
+                <a:spcPts val="336"/>
+              </a:spcAft>
+            </a:pPr>
             <a:r>
               <a:rPr lang="en-US" altLang="zh-CN" sz="1400">
                 <a:solidFill>
                   <a:srgbClr val="000000"/>
                 </a:solidFill>
-                <a:latin typeface="Calibri" panose="020F0502020204030204" pitchFamily="34" charset="0"/>
+                <a:latin typeface="Times New Roman" panose="02020603050405020304" pitchFamily="18" charset="0"/>
+                <a:ea typeface="微软雅黑" panose="020B0503020204020204" pitchFamily="34" charset="-122"/>
               </a:rPr>
               <a:t>RTu1A-3</a:t>
             </a:r>
@@ -4049,7 +4149,8 @@
               <a:solidFill>
                 <a:srgbClr val="000000"/>
               </a:solidFill>
-              <a:latin typeface="Calibri" panose="020F0502020204030204" pitchFamily="34" charset="0"/>
+              <a:latin typeface="Times New Roman" panose="02020603050405020304" pitchFamily="18" charset="0"/>
+              <a:ea typeface="微软雅黑" panose="020B0503020204020204" pitchFamily="34" charset="-122"/>
             </a:endParaRPr>
           </a:p>
         </p:txBody>
@@ -4057,7 +4158,7 @@
     </p:spTree>
     <p:extLst>
       <p:ext uri="{BB962C8B-B14F-4D97-AF65-F5344CB8AC3E}">
-        <p14:creationId xmlns:p14="http://schemas.microsoft.com/office/powerpoint/2010/main" val="4117857820"/>
+        <p14:creationId xmlns:p14="http://schemas.microsoft.com/office/powerpoint/2010/main" val="1849003105"/>
       </p:ext>
     </p:extLst>
   </p:cSld>
@@ -4089,7 +4190,7 @@
           <p:cNvPr id="3" name="LogoLeft">
             <a:extLst>
               <a:ext uri="{FF2B5EF4-FFF2-40B4-BE49-F238E27FC236}">
-                <a16:creationId xmlns:a16="http://schemas.microsoft.com/office/drawing/2014/main" id="{19F1F304-ABF4-6BC3-2907-2C84AB06F6E9}"/>
+                <a16:creationId xmlns:a16="http://schemas.microsoft.com/office/drawing/2014/main" id="{49A3D214-7C80-A6AC-8B4B-9D4F5AC46035}"/>
               </a:ext>
             </a:extLst>
           </p:cNvPr>
@@ -4125,7 +4226,7 @@
           <p:cNvPr id="4" name="Title">
             <a:extLst>
               <a:ext uri="{FF2B5EF4-FFF2-40B4-BE49-F238E27FC236}">
-                <a16:creationId xmlns:a16="http://schemas.microsoft.com/office/drawing/2014/main" id="{B377D5FF-517C-8FF6-F10F-4707D93D334F}"/>
+                <a16:creationId xmlns:a16="http://schemas.microsoft.com/office/drawing/2014/main" id="{D488618F-39D8-3176-48E8-0DD46612CE99}"/>
               </a:ext>
             </a:extLst>
           </p:cNvPr>
@@ -4135,7 +4236,7 @@
         <p:spPr>
           <a:xfrm>
             <a:off x="508000" y="114300"/>
-            <a:ext cx="11176000" cy="769441"/>
+            <a:ext cx="11176000" cy="834011"/>
           </a:xfrm>
           <a:prstGeom prst="rect">
             <a:avLst/>
@@ -4148,13 +4249,21 @@
           </a:bodyPr>
           <a:lstStyle/>
           <a:p>
-            <a:pPr algn="ctr"/>
+            <a:pPr algn="ctr">
+              <a:lnSpc>
+                <a:spcPct val="120000"/>
+              </a:lnSpc>
+              <a:spcAft>
+                <a:spcPts val="1056"/>
+              </a:spcAft>
+            </a:pPr>
             <a:r>
               <a:rPr lang="en-US" altLang="zh-CN" sz="4400">
                 <a:solidFill>
                   <a:srgbClr val="000000"/>
                 </a:solidFill>
-                <a:latin typeface="Franklin Gothic Book" panose="020B0503020102020204" pitchFamily="34" charset="0"/>
+                <a:latin typeface="Times New Roman" panose="02020603050405020304" pitchFamily="18" charset="0"/>
+                <a:ea typeface="微软雅黑" panose="020B0503020204020204" pitchFamily="34" charset="-122"/>
               </a:rPr>
               <a:t>Motivation</a:t>
             </a:r>
@@ -4162,7 +4271,8 @@
               <a:solidFill>
                 <a:srgbClr val="000000"/>
               </a:solidFill>
-              <a:latin typeface="Franklin Gothic Book" panose="020B0503020102020204" pitchFamily="34" charset="0"/>
+              <a:latin typeface="Times New Roman" panose="02020603050405020304" pitchFamily="18" charset="0"/>
+              <a:ea typeface="微软雅黑" panose="020B0503020204020204" pitchFamily="34" charset="-122"/>
             </a:endParaRPr>
           </a:p>
         </p:txBody>
@@ -4172,7 +4282,7 @@
           <p:cNvPr id="5" name="LeadIn">
             <a:extLst>
               <a:ext uri="{FF2B5EF4-FFF2-40B4-BE49-F238E27FC236}">
-                <a16:creationId xmlns:a16="http://schemas.microsoft.com/office/drawing/2014/main" id="{E13127CF-0A9A-C41A-4992-1EBA460029F3}"/>
+                <a16:creationId xmlns:a16="http://schemas.microsoft.com/office/drawing/2014/main" id="{88639B2E-2A1E-3A77-85CF-E88D4C97438D}"/>
               </a:ext>
             </a:extLst>
           </p:cNvPr>
@@ -4182,7 +4292,7 @@
         <p:spPr>
           <a:xfrm>
             <a:off x="927100" y="1270000"/>
-            <a:ext cx="7620000" cy="584775"/>
+            <a:ext cx="7620000" cy="631711"/>
           </a:xfrm>
           <a:prstGeom prst="rect">
             <a:avLst/>
@@ -4195,12 +4305,21 @@
           </a:bodyPr>
           <a:lstStyle/>
           <a:p>
+            <a:pPr>
+              <a:lnSpc>
+                <a:spcPct val="120000"/>
+              </a:lnSpc>
+              <a:spcAft>
+                <a:spcPts val="768"/>
+              </a:spcAft>
+            </a:pPr>
             <a:r>
               <a:rPr lang="en-US" altLang="zh-CN" sz="3200" b="1" i="1">
                 <a:solidFill>
                   <a:srgbClr val="000000"/>
                 </a:solidFill>
-                <a:latin typeface="Franklin Gothic Book" panose="020B0503020102020204" pitchFamily="34" charset="0"/>
+                <a:latin typeface="Times New Roman" panose="02020603050405020304" pitchFamily="18" charset="0"/>
+                <a:ea typeface="微软雅黑" panose="020B0503020204020204" pitchFamily="34" charset="-122"/>
               </a:rPr>
               <a:t>Wideband LNA trade-off:</a:t>
             </a:r>
@@ -4208,7 +4327,8 @@
               <a:solidFill>
                 <a:srgbClr val="000000"/>
               </a:solidFill>
-              <a:latin typeface="Franklin Gothic Book" panose="020B0503020102020204" pitchFamily="34" charset="0"/>
+              <a:latin typeface="Times New Roman" panose="02020603050405020304" pitchFamily="18" charset="0"/>
+              <a:ea typeface="微软雅黑" panose="020B0503020204020204" pitchFamily="34" charset="-122"/>
             </a:endParaRPr>
           </a:p>
         </p:txBody>
@@ -4218,7 +4338,7 @@
           <p:cNvPr id="6" name="L1Bullets">
             <a:extLst>
               <a:ext uri="{FF2B5EF4-FFF2-40B4-BE49-F238E27FC236}">
-                <a16:creationId xmlns:a16="http://schemas.microsoft.com/office/drawing/2014/main" id="{42B7800F-74E2-B030-CE85-E338CB706052}"/>
+                <a16:creationId xmlns:a16="http://schemas.microsoft.com/office/drawing/2014/main" id="{F75686C4-A7A2-1810-E75F-5FB1BE509026}"/>
               </a:ext>
             </a:extLst>
           </p:cNvPr>
@@ -4227,8 +4347,8 @@
         </p:nvSpPr>
         <p:spPr>
           <a:xfrm>
-            <a:off x="927100" y="1968500"/>
-            <a:ext cx="9906000" cy="1569660"/>
+            <a:off x="927100" y="1968499"/>
+            <a:ext cx="9906000" cy="2286000"/>
           </a:xfrm>
           <a:prstGeom prst="rect">
             <a:avLst/>
@@ -4237,16 +4357,25 @@
         </p:spPr>
         <p:txBody>
           <a:bodyPr vert="horz" wrap="square" rtlCol="0">
-            <a:spAutoFit/>
+            <a:noAutofit/>
           </a:bodyPr>
           <a:lstStyle/>
           <a:p>
+            <a:pPr>
+              <a:lnSpc>
+                <a:spcPct val="120000"/>
+              </a:lnSpc>
+              <a:spcAft>
+                <a:spcPts val="768"/>
+              </a:spcAft>
+            </a:pPr>
             <a:r>
               <a:rPr lang="en-US" altLang="zh-CN" sz="3200">
                 <a:solidFill>
                   <a:srgbClr val="000000"/>
                 </a:solidFill>
-                <a:latin typeface="Franklin Gothic Book" panose="020B0503020102020204" pitchFamily="34" charset="0"/>
+                <a:latin typeface="Times New Roman" panose="02020603050405020304" pitchFamily="18" charset="0"/>
+                <a:ea typeface="微软雅黑" panose="020B0503020204020204" pitchFamily="34" charset="-122"/>
               </a:rPr>
               <a:t>•  6-12 GHz bandwidth with 0.8-1.5 dB NF</a:t>
             </a:r>
@@ -4255,7 +4384,8 @@
                 <a:solidFill>
                   <a:srgbClr val="000000"/>
                 </a:solidFill>
-                <a:latin typeface="Franklin Gothic Book" panose="020B0503020102020204" pitchFamily="34" charset="0"/>
+                <a:latin typeface="Times New Roman" panose="02020603050405020304" pitchFamily="18" charset="0"/>
+                <a:ea typeface="微软雅黑" panose="020B0503020204020204" pitchFamily="34" charset="-122"/>
               </a:rPr>
             </a:br>
             <a:r>
@@ -4263,7 +4393,8 @@
                 <a:solidFill>
                   <a:srgbClr val="000000"/>
                 </a:solidFill>
-                <a:latin typeface="Franklin Gothic Book" panose="020B0503020102020204" pitchFamily="34" charset="0"/>
+                <a:latin typeface="Times New Roman" panose="02020603050405020304" pitchFamily="18" charset="0"/>
+                <a:ea typeface="微软雅黑" panose="020B0503020204020204" pitchFamily="34" charset="-122"/>
               </a:rPr>
               <a:t>•  Transformer-based input matching, ESD-robust</a:t>
             </a:r>
@@ -4272,7 +4403,8 @@
                 <a:solidFill>
                   <a:srgbClr val="000000"/>
                 </a:solidFill>
-                <a:latin typeface="Franklin Gothic Book" panose="020B0503020102020204" pitchFamily="34" charset="0"/>
+                <a:latin typeface="Times New Roman" panose="02020603050405020304" pitchFamily="18" charset="0"/>
+                <a:ea typeface="微软雅黑" panose="020B0503020204020204" pitchFamily="34" charset="-122"/>
               </a:rPr>
             </a:br>
             <a:r>
@@ -4280,7 +4412,8 @@
                 <a:solidFill>
                   <a:srgbClr val="000000"/>
                 </a:solidFill>
-                <a:latin typeface="Franklin Gothic Book" panose="020B0503020102020204" pitchFamily="34" charset="0"/>
+                <a:latin typeface="Times New Roman" panose="02020603050405020304" pitchFamily="18" charset="0"/>
+                <a:ea typeface="微软雅黑" panose="020B0503020204020204" pitchFamily="34" charset="-122"/>
               </a:rPr>
               <a:t>•  Challenge: BW-NF-linearity co-design in SOI CMOS</a:t>
             </a:r>
@@ -4288,7 +4421,8 @@
               <a:solidFill>
                 <a:srgbClr val="000000"/>
               </a:solidFill>
-              <a:latin typeface="Franklin Gothic Book" panose="020B0503020102020204" pitchFamily="34" charset="0"/>
+              <a:latin typeface="Times New Roman" panose="02020603050405020304" pitchFamily="18" charset="0"/>
+              <a:ea typeface="微软雅黑" panose="020B0503020204020204" pitchFamily="34" charset="-122"/>
             </a:endParaRPr>
           </a:p>
         </p:txBody>
@@ -4298,7 +4432,7 @@
           <p:cNvPr id="7" name="FormulaCaption">
             <a:extLst>
               <a:ext uri="{FF2B5EF4-FFF2-40B4-BE49-F238E27FC236}">
-                <a16:creationId xmlns:a16="http://schemas.microsoft.com/office/drawing/2014/main" id="{7CAF54D6-37F4-88EF-68C0-9EDCC9F519F2}"/>
+                <a16:creationId xmlns:a16="http://schemas.microsoft.com/office/drawing/2014/main" id="{08EBEF16-94A3-3E8B-FB35-9FA83A9CB6CA}"/>
               </a:ext>
             </a:extLst>
           </p:cNvPr>
@@ -4307,8 +4441,8 @@
         </p:nvSpPr>
         <p:spPr>
           <a:xfrm>
-            <a:off x="927100" y="4064000"/>
-            <a:ext cx="6350000" cy="400110"/>
+            <a:off x="927100" y="4445000"/>
+            <a:ext cx="6350000" cy="429413"/>
           </a:xfrm>
           <a:prstGeom prst="rect">
             <a:avLst/>
@@ -4321,12 +4455,21 @@
           </a:bodyPr>
           <a:lstStyle/>
           <a:p>
+            <a:pPr>
+              <a:lnSpc>
+                <a:spcPct val="120000"/>
+              </a:lnSpc>
+              <a:spcAft>
+                <a:spcPts val="480"/>
+              </a:spcAft>
+            </a:pPr>
             <a:r>
               <a:rPr lang="en-US" altLang="zh-CN" sz="2000">
                 <a:solidFill>
                   <a:srgbClr val="000000"/>
                 </a:solidFill>
-                <a:latin typeface="Franklin Gothic Book" panose="020B0503020102020204" pitchFamily="34" charset="0"/>
+                <a:latin typeface="Times New Roman" panose="02020603050405020304" pitchFamily="18" charset="0"/>
+                <a:ea typeface="微软雅黑" panose="020B0503020204020204" pitchFamily="34" charset="-122"/>
               </a:rPr>
               <a:t>Noise factor definition (textbook):</a:t>
             </a:r>
@@ -4334,7 +4477,8 @@
               <a:solidFill>
                 <a:srgbClr val="000000"/>
               </a:solidFill>
-              <a:latin typeface="Franklin Gothic Book" panose="020B0503020102020204" pitchFamily="34" charset="0"/>
+              <a:latin typeface="Times New Roman" panose="02020603050405020304" pitchFamily="18" charset="0"/>
+              <a:ea typeface="微软雅黑" panose="020B0503020204020204" pitchFamily="34" charset="-122"/>
             </a:endParaRPr>
           </a:p>
         </p:txBody>
@@ -4344,7 +4488,7 @@
           <p:cNvPr id="9" name="FooterBand">
             <a:extLst>
               <a:ext uri="{FF2B5EF4-FFF2-40B4-BE49-F238E27FC236}">
-                <a16:creationId xmlns:a16="http://schemas.microsoft.com/office/drawing/2014/main" id="{81192228-3AF1-7A71-56BD-7A0D989CFA27}"/>
+                <a16:creationId xmlns:a16="http://schemas.microsoft.com/office/drawing/2014/main" id="{F1D05B3E-4295-1FBF-A342-154CE15C521D}"/>
               </a:ext>
             </a:extLst>
           </p:cNvPr>
@@ -4380,7 +4524,7 @@
           <p:cNvPr id="10" name="PageNo">
             <a:extLst>
               <a:ext uri="{FF2B5EF4-FFF2-40B4-BE49-F238E27FC236}">
-                <a16:creationId xmlns:a16="http://schemas.microsoft.com/office/drawing/2014/main" id="{900901E0-3396-16E3-F3F5-001C914C356B}"/>
+                <a16:creationId xmlns:a16="http://schemas.microsoft.com/office/drawing/2014/main" id="{08F5E3F5-EE8B-56FE-5317-3E6F71F984E6}"/>
               </a:ext>
             </a:extLst>
           </p:cNvPr>
@@ -4390,7 +4534,7 @@
         <p:spPr>
           <a:xfrm>
             <a:off x="5588000" y="6426200"/>
-            <a:ext cx="1016000" cy="400110"/>
+            <a:ext cx="1016000" cy="429413"/>
           </a:xfrm>
           <a:prstGeom prst="rect">
             <a:avLst/>
@@ -4403,13 +4547,21 @@
           </a:bodyPr>
           <a:lstStyle/>
           <a:p>
-            <a:pPr algn="ctr"/>
+            <a:pPr algn="ctr">
+              <a:lnSpc>
+                <a:spcPct val="120000"/>
+              </a:lnSpc>
+              <a:spcAft>
+                <a:spcPts val="480"/>
+              </a:spcAft>
+            </a:pPr>
             <a:r>
               <a:rPr lang="en-US" altLang="zh-CN" sz="2000">
                 <a:solidFill>
                   <a:srgbClr val="000000"/>
                 </a:solidFill>
-                <a:latin typeface="Calibri" panose="020F0502020204030204" pitchFamily="34" charset="0"/>
+                <a:latin typeface="Times New Roman" panose="02020603050405020304" pitchFamily="18" charset="0"/>
+                <a:ea typeface="微软雅黑" panose="020B0503020204020204" pitchFamily="34" charset="-122"/>
               </a:rPr>
               <a:t>2</a:t>
             </a:r>
@@ -4417,7 +4569,8 @@
               <a:solidFill>
                 <a:srgbClr val="000000"/>
               </a:solidFill>
-              <a:latin typeface="Calibri" panose="020F0502020204030204" pitchFamily="34" charset="0"/>
+              <a:latin typeface="Times New Roman" panose="02020603050405020304" pitchFamily="18" charset="0"/>
+              <a:ea typeface="微软雅黑" panose="020B0503020204020204" pitchFamily="34" charset="-122"/>
             </a:endParaRPr>
           </a:p>
         </p:txBody>
@@ -4427,7 +4580,7 @@
           <p:cNvPr id="11" name="SessionId">
             <a:extLst>
               <a:ext uri="{FF2B5EF4-FFF2-40B4-BE49-F238E27FC236}">
-                <a16:creationId xmlns:a16="http://schemas.microsoft.com/office/drawing/2014/main" id="{CCFFE83B-817A-9D50-F85B-ABBB14CDFA5E}"/>
+                <a16:creationId xmlns:a16="http://schemas.microsoft.com/office/drawing/2014/main" id="{11721A9A-CAC5-33A7-A129-9BE9977217E3}"/>
               </a:ext>
             </a:extLst>
           </p:cNvPr>
@@ -4437,7 +4590,7 @@
         <p:spPr>
           <a:xfrm>
             <a:off x="9906000" y="6451600"/>
-            <a:ext cx="2159000" cy="307777"/>
+            <a:ext cx="2159000" cy="328360"/>
           </a:xfrm>
           <a:prstGeom prst="rect">
             <a:avLst/>
@@ -4450,13 +4603,21 @@
           </a:bodyPr>
           <a:lstStyle/>
           <a:p>
-            <a:pPr algn="ctr"/>
+            <a:pPr algn="ctr">
+              <a:lnSpc>
+                <a:spcPct val="120000"/>
+              </a:lnSpc>
+              <a:spcAft>
+                <a:spcPts val="336"/>
+              </a:spcAft>
+            </a:pPr>
             <a:r>
               <a:rPr lang="en-US" altLang="zh-CN" sz="1400">
                 <a:solidFill>
                   <a:srgbClr val="000000"/>
                 </a:solidFill>
-                <a:latin typeface="Calibri" panose="020F0502020204030204" pitchFamily="34" charset="0"/>
+                <a:latin typeface="Times New Roman" panose="02020603050405020304" pitchFamily="18" charset="0"/>
+                <a:ea typeface="微软雅黑" panose="020B0503020204020204" pitchFamily="34" charset="-122"/>
               </a:rPr>
               <a:t>RTu1A-3</a:t>
             </a:r>
@@ -4464,21 +4625,22 @@
               <a:solidFill>
                 <a:srgbClr val="000000"/>
               </a:solidFill>
-              <a:latin typeface="Calibri" panose="020F0502020204030204" pitchFamily="34" charset="0"/>
+              <a:latin typeface="Times New Roman" panose="02020603050405020304" pitchFamily="18" charset="0"/>
+              <a:ea typeface="微软雅黑" panose="020B0503020204020204" pitchFamily="34" charset="-122"/>
             </a:endParaRPr>
           </a:p>
         </p:txBody>
       </p:sp>
       <p:sp>
         <p:nvSpPr>
-          <p:cNvPr id="12" name="Equation 1"/>
+          <p:cNvPr id="12" name="Equation3"/>
           <p:cNvSpPr/>
           <p:nvPr/>
         </p:nvSpPr>
         <p:spPr>
           <a:xfrm>
-            <a:off x="2540000" y="4699000"/>
-            <a:ext cx="7112000" cy="1016000"/>
+            <a:off x="3175000" y="5016500"/>
+            <a:ext cx="5715000" cy="762000"/>
           </a:xfrm>
           <a:prstGeom prst="rect">
             <a:avLst/>
@@ -4508,10 +4670,10 @@
                       <m:sSub>
                         <m:e>
                           <m:r>
-                            <a:rPr lang="en-US" i="1" sz="2400">
+                            <a:rPr lang="en-US" i="0" sz="2400">
                               <a:latin typeface="Cambria Math"/>
                             </a:rPr>
-                            <m:t>S</m:t>
+                            <m:t>SNR</m:t>
                           </m:r>
                         </m:e>
                         <m:sub>
@@ -4519,7 +4681,7 @@
                             <a:rPr lang="en-US" i="1" sz="2400">
                               <a:latin typeface="Cambria Math"/>
                             </a:rPr>
-                            <m:t>i</m:t>
+                            <m:t>in</m:t>
                           </m:r>
                         </m:sub>
                       </m:sSub>
@@ -4528,10 +4690,10 @@
                       <m:sSub>
                         <m:e>
                           <m:r>
-                            <a:rPr lang="en-US" i="1" sz="2400">
+                            <a:rPr lang="en-US" i="0" sz="2400">
                               <a:latin typeface="Cambria Math"/>
                             </a:rPr>
-                            <m:t>S</m:t>
+                            <m:t>SNR</m:t>
                           </m:r>
                         </m:e>
                         <m:sub>
@@ -4539,102 +4701,12 @@
                             <a:rPr lang="en-US" i="1" sz="2400">
                               <a:latin typeface="Cambria Math"/>
                             </a:rPr>
-                            <m:t>o</m:t>
+                            <m:t>out</m:t>
                           </m:r>
                         </m:sub>
                       </m:sSub>
                     </m:den>
                   </m:f>
-                  <m:r>
-                    <a:rPr lang="en-US" i="0" sz="2400">
-                      <a:latin typeface="Cambria Math"/>
-                    </a:rPr>
-                    <m:t>=</m:t>
-                  </m:r>
-                  <m:f>
-                    <m:num>
-                      <m:r>
-                        <a:rPr lang="en-US" i="0" sz="2400">
-                          <a:latin typeface="Cambria Math"/>
-                        </a:rPr>
-                        <m:t>1</m:t>
-                      </m:r>
-                    </m:num>
-                    <m:den>
-                      <m:sSub>
-                        <m:e>
-                          <m:r>
-                            <a:rPr lang="en-US" i="1" sz="2400">
-                              <a:latin typeface="Cambria Math"/>
-                            </a:rPr>
-                            <m:t>G</m:t>
-                          </m:r>
-                        </m:e>
-                        <m:sub>
-                          <m:r>
-                            <a:rPr lang="en-US" i="1" sz="2400">
-                              <a:latin typeface="Cambria Math"/>
-                            </a:rPr>
-                            <m:t>t</m:t>
-                          </m:r>
-                        </m:sub>
-                      </m:sSub>
-                    </m:den>
-                  </m:f>
-                  <m:r>
-                    <a:rPr lang="en-US" i="0" sz="2400">
-                      <a:latin typeface="Cambria Math"/>
-                    </a:rPr>
-                    <m:t>,</m:t>
-                  </m:r>
-                  <m:r>
-                    <a:rPr lang="en-US" i="0" sz="2400">
-                      <a:latin typeface="Cambria Math"/>
-                    </a:rPr>
-                    <m:t>  </m:t>
-                  </m:r>
-                  <m:r>
-                    <a:rPr lang="en-US" i="0" sz="2400">
-                      <a:latin typeface="Cambria Math"/>
-                    </a:rPr>
-                    <m:t>NF</m:t>
-                  </m:r>
-                  <m:r>
-                    <a:rPr lang="en-US" i="0" sz="2400">
-                      <a:latin typeface="Cambria Math"/>
-                    </a:rPr>
-                    <m:t>=</m:t>
-                  </m:r>
-                  <m:r>
-                    <a:rPr lang="en-US" i="0" sz="2400">
-                      <a:latin typeface="Cambria Math"/>
-                    </a:rPr>
-                    <m:t>10</m:t>
-                  </m:r>
-                  <m:sSub>
-                    <m:e>
-                      <m:r>
-                        <a:rPr lang="en-US" i="0" sz="2400">
-                          <a:latin typeface="Cambria Math"/>
-                        </a:rPr>
-                        <m:t>log</m:t>
-                      </m:r>
-                    </m:e>
-                    <m:sub>
-                      <m:r>
-                        <a:rPr lang="en-US" i="0" sz="2400">
-                          <a:latin typeface="Cambria Math"/>
-                        </a:rPr>
-                        <m:t>10</m:t>
-                      </m:r>
-                    </m:sub>
-                  </m:sSub>
-                  <m:r>
-                    <a:rPr lang="en-US" i="1" sz="2400">
-                      <a:latin typeface="Cambria Math"/>
-                    </a:rPr>
-                    <m:t>F</m:t>
-                  </m:r>
                 </m:oMath>
               </m:oMathPara>
             </a14:m>
@@ -4644,7 +4716,7 @@
     </p:spTree>
     <p:extLst>
       <p:ext uri="{BB962C8B-B14F-4D97-AF65-F5344CB8AC3E}">
-        <p14:creationId xmlns:p14="http://schemas.microsoft.com/office/powerpoint/2010/main" val="645160402"/>
+        <p14:creationId xmlns:p14="http://schemas.microsoft.com/office/powerpoint/2010/main" val="3714742795"/>
       </p:ext>
     </p:extLst>
   </p:cSld>

</xml_diff>